<commit_message>
Regenerate schematic pattern sample catalog
- add a reproducible schematic sample generator
- include all 25 schematic kinds in samples/schematic-patterns
- regenerate schematic-patterns DeckSpec, PPTX, and Studio HTML
- bump packages to v0.2.5

Co-authored-by: Copilot <223556219+Copilot@users.noreply.github.com>
</commit_message>
<xml_diff>
--- a/samples/schematic-patterns.pptx
+++ b/samples/schematic-patterns.pptx
@@ -5,7 +5,7 @@
     <p:sldMasterId id="2147483648" r:id="rId1"/>
   </p:sldMasterIdLst>
   <p:notesMasterIdLst>
-    <p:notesMasterId r:id="rId7"/>
+    <p:notesMasterId r:id="rId28"/>
   </p:notesMasterIdLst>
   <p:sldIdLst>
     <p:sldId id="256" r:id="rId2"/>
@@ -13,6 +13,27 @@
     <p:sldId id="258" r:id="rId4"/>
     <p:sldId id="259" r:id="rId5"/>
     <p:sldId id="260" r:id="rId6"/>
+    <p:sldId id="261" r:id="rId7"/>
+    <p:sldId id="262" r:id="rId8"/>
+    <p:sldId id="263" r:id="rId9"/>
+    <p:sldId id="264" r:id="rId10"/>
+    <p:sldId id="265" r:id="rId11"/>
+    <p:sldId id="266" r:id="rId12"/>
+    <p:sldId id="267" r:id="rId13"/>
+    <p:sldId id="268" r:id="rId14"/>
+    <p:sldId id="269" r:id="rId15"/>
+    <p:sldId id="270" r:id="rId16"/>
+    <p:sldId id="271" r:id="rId17"/>
+    <p:sldId id="272" r:id="rId18"/>
+    <p:sldId id="273" r:id="rId19"/>
+    <p:sldId id="274" r:id="rId20"/>
+    <p:sldId id="275" r:id="rId21"/>
+    <p:sldId id="276" r:id="rId22"/>
+    <p:sldId id="277" r:id="rId23"/>
+    <p:sldId id="278" r:id="rId24"/>
+    <p:sldId id="279" r:id="rId25"/>
+    <p:sldId id="280" r:id="rId26"/>
+    <p:sldId id="281" r:id="rId27"/>
   </p:sldIdLst>
   <p:sldSz cx="12192000" cy="6858000"/>
   <p:notesSz cx="6858000" cy="12192000"/>
@@ -506,10 +527,10 @@
           <a:p>
             <a:r>
               <a:rPr lang="en-US" dirty="0"/>
-              <a:t>generate_schematic で生成した安全な図解プリセットの例です。
-Slide 1: 横型フロー: 作成から検証までを迷わず進める
-flow-visual: flow schematic sample
-flow-visual long description: flow schematic sample generated from a safe preset to demonstrate Slideland-inspired layouts in pptcreater.</a:t>
+              <a:t>Pattern: table. Style profile: minimal. Two-column comparison or structured attribute table.
+Slide 1: 表: 論点と判断材料をそろえる
+table-visual: 表 (table) schematic sample
+table-visual long description: 表 (table) のサンプルです。Two-column comparison or structured attribute table. pptcreater の安全なschematicプリセットで生成しています。</a:t>
             </a:r>
             <a:endParaRPr lang="en-US" dirty="0"/>
           </a:p>
@@ -551,6 +572,916 @@
 </p:notes>
 </file>
 
+<file path=ppt/notesSlides/notesSlide10.xml><?xml version="1.0" encoding="utf-8"?>
+<p:notes xmlns:a="http://schemas.openxmlformats.org/drawingml/2006/main" xmlns:r="http://schemas.openxmlformats.org/officeDocument/2006/relationships" xmlns:p="http://schemas.openxmlformats.org/presentationml/2006/main">
+  <p:cSld>
+    <p:spTree>
+      <p:nvGrpSpPr>
+        <p:cNvPr id="1" name=""/>
+        <p:cNvGrpSpPr/>
+        <p:nvPr/>
+      </p:nvGrpSpPr>
+      <p:grpSpPr>
+        <a:xfrm>
+          <a:off x="0" y="0"/>
+          <a:ext cx="0" cy="0"/>
+          <a:chOff x="0" y="0"/>
+          <a:chExt cx="0" cy="0"/>
+        </a:xfrm>
+      </p:grpSpPr>
+      <p:sp>
+        <p:nvSpPr>
+          <p:cNvPr id="2" name="Slide Image Placeholder 1"/>
+          <p:cNvSpPr>
+            <a:spLocks noGrp="1" noRot="1" noChangeAspect="1"/>
+          </p:cNvSpPr>
+          <p:nvPr>
+            <p:ph type="sldImg"/>
+          </p:nvPr>
+        </p:nvSpPr>
+        <p:spPr/>
+      </p:sp>
+      <p:sp>
+        <p:nvSpPr>
+          <p:cNvPr id="3" name="Notes Placeholder 2"/>
+          <p:cNvSpPr>
+            <a:spLocks noGrp="1"/>
+          </p:cNvSpPr>
+          <p:nvPr>
+            <p:ph type="body" idx="1"/>
+          </p:nvPr>
+        </p:nvSpPr>
+        <p:spPr/>
+        <p:txBody>
+          <a:bodyPr/>
+          <a:lstStyle/>
+          <a:p>
+            <a:r>
+              <a:rPr lang="en-US" dirty="0"/>
+              <a:t>Pattern: matrix. Style profile: technical. 2x2 positioning map for prioritization or segmentation.
+Slide 10: マトリクス: 優先度を2軸で判断する
+matrix-visual: マトリクス (matrix) schematic sample
+matrix-visual long description: マトリクス (matrix) のサンプルです。2x2 positioning map for prioritization or segmentation. pptcreater の安全なschematicプリセットで生成しています。</a:t>
+            </a:r>
+            <a:endParaRPr lang="en-US" dirty="0"/>
+          </a:p>
+        </p:txBody>
+      </p:sp>
+      <p:sp>
+        <p:nvSpPr>
+          <p:cNvPr id="4" name="Slide Number Placeholder 3"/>
+          <p:cNvSpPr>
+            <a:spLocks noGrp="1"/>
+          </p:cNvSpPr>
+          <p:nvPr>
+            <p:ph type="sldNum" sz="quarter" idx="10"/>
+          </p:nvPr>
+        </p:nvSpPr>
+        <p:spPr/>
+        <p:txBody>
+          <a:bodyPr/>
+          <a:lstStyle/>
+          <a:p>
+            <a:fld id="{F7021451-1387-4CA6-816F-3879F97B5CBC}" type="slidenum">
+              <a:rPr lang="en-US"/>
+              <a:t>10</a:t>
+            </a:fld>
+            <a:endParaRPr lang="en-US"/>
+          </a:p>
+        </p:txBody>
+      </p:sp>
+    </p:spTree>
+    <p:extLst>
+      <p:ext uri="{BB962C8B-B14F-4D97-AF65-F5344CB8AC3E}">
+        <p14:creationId xmlns:p14="http://schemas.microsoft.com/office/powerpoint/2010/main" val="1024086991"/>
+      </p:ext>
+    </p:extLst>
+  </p:cSld>
+  <p:clrMapOvr>
+    <a:masterClrMapping/>
+  </p:clrMapOvr>
+</p:notes>
+</file>
+
+<file path=ppt/notesSlides/notesSlide11.xml><?xml version="1.0" encoding="utf-8"?>
+<p:notes xmlns:a="http://schemas.openxmlformats.org/drawingml/2006/main" xmlns:r="http://schemas.openxmlformats.org/officeDocument/2006/relationships" xmlns:p="http://schemas.openxmlformats.org/presentationml/2006/main">
+  <p:cSld>
+    <p:spTree>
+      <p:nvGrpSpPr>
+        <p:cNvPr id="1" name=""/>
+        <p:cNvGrpSpPr/>
+        <p:nvPr/>
+      </p:nvGrpSpPr>
+      <p:grpSpPr>
+        <a:xfrm>
+          <a:off x="0" y="0"/>
+          <a:ext cx="0" cy="0"/>
+          <a:chOff x="0" y="0"/>
+          <a:chExt cx="0" cy="0"/>
+        </a:xfrm>
+      </p:grpSpPr>
+      <p:sp>
+        <p:nvSpPr>
+          <p:cNvPr id="2" name="Slide Image Placeholder 1"/>
+          <p:cNvSpPr>
+            <a:spLocks noGrp="1" noRot="1" noChangeAspect="1"/>
+          </p:cNvSpPr>
+          <p:nvPr>
+            <p:ph type="sldImg"/>
+          </p:nvPr>
+        </p:nvSpPr>
+        <p:spPr/>
+      </p:sp>
+      <p:sp>
+        <p:nvSpPr>
+          <p:cNvPr id="3" name="Notes Placeholder 2"/>
+          <p:cNvSpPr>
+            <a:spLocks noGrp="1"/>
+          </p:cNvSpPr>
+          <p:nvPr>
+            <p:ph type="body" idx="1"/>
+          </p:nvPr>
+        </p:nvSpPr>
+        <p:spPr/>
+        <p:txBody>
+          <a:bodyPr/>
+          <a:lstStyle/>
+          <a:p>
+            <a:r>
+              <a:rPr lang="en-US" dirty="0"/>
+              <a:t>Pattern: venn. Style profile: minimal. Overlap among two or three sets with an intersection message.
+Slide 11: ベン図: 重なりから価値を説明する
+venn-visual: ベン図 (venn) schematic sample
+venn-visual long description: ベン図 (venn) のサンプルです。Overlap among two or three sets with an intersection message. pptcreater の安全なschematicプリセットで生成しています。</a:t>
+            </a:r>
+            <a:endParaRPr lang="en-US" dirty="0"/>
+          </a:p>
+        </p:txBody>
+      </p:sp>
+      <p:sp>
+        <p:nvSpPr>
+          <p:cNvPr id="4" name="Slide Number Placeholder 3"/>
+          <p:cNvSpPr>
+            <a:spLocks noGrp="1"/>
+          </p:cNvSpPr>
+          <p:nvPr>
+            <p:ph type="sldNum" sz="quarter" idx="10"/>
+          </p:nvPr>
+        </p:nvSpPr>
+        <p:spPr/>
+        <p:txBody>
+          <a:bodyPr/>
+          <a:lstStyle/>
+          <a:p>
+            <a:fld id="{F7021451-1387-4CA6-816F-3879F97B5CBC}" type="slidenum">
+              <a:rPr lang="en-US"/>
+              <a:t>11</a:t>
+            </a:fld>
+            <a:endParaRPr lang="en-US"/>
+          </a:p>
+        </p:txBody>
+      </p:sp>
+    </p:spTree>
+    <p:extLst>
+      <p:ext uri="{BB962C8B-B14F-4D97-AF65-F5344CB8AC3E}">
+        <p14:creationId xmlns:p14="http://schemas.microsoft.com/office/powerpoint/2010/main" val="1024086991"/>
+      </p:ext>
+    </p:extLst>
+  </p:cSld>
+  <p:clrMapOvr>
+    <a:masterClrMapping/>
+  </p:clrMapOvr>
+</p:notes>
+</file>
+
+<file path=ppt/notesSlides/notesSlide12.xml><?xml version="1.0" encoding="utf-8"?>
+<p:notes xmlns:a="http://schemas.openxmlformats.org/drawingml/2006/main" xmlns:r="http://schemas.openxmlformats.org/officeDocument/2006/relationships" xmlns:p="http://schemas.openxmlformats.org/presentationml/2006/main">
+  <p:cSld>
+    <p:spTree>
+      <p:nvGrpSpPr>
+        <p:cNvPr id="1" name=""/>
+        <p:cNvGrpSpPr/>
+        <p:nvPr/>
+      </p:nvGrpSpPr>
+      <p:grpSpPr>
+        <a:xfrm>
+          <a:off x="0" y="0"/>
+          <a:ext cx="0" cy="0"/>
+          <a:chOff x="0" y="0"/>
+          <a:chExt cx="0" cy="0"/>
+        </a:xfrm>
+      </p:grpSpPr>
+      <p:sp>
+        <p:nvSpPr>
+          <p:cNvPr id="2" name="Slide Image Placeholder 1"/>
+          <p:cNvSpPr>
+            <a:spLocks noGrp="1" noRot="1" noChangeAspect="1"/>
+          </p:cNvSpPr>
+          <p:nvPr>
+            <p:ph type="sldImg"/>
+          </p:nvPr>
+        </p:nvSpPr>
+        <p:spPr/>
+      </p:sp>
+      <p:sp>
+        <p:nvSpPr>
+          <p:cNvPr id="3" name="Notes Placeholder 2"/>
+          <p:cNvSpPr>
+            <a:spLocks noGrp="1"/>
+          </p:cNvSpPr>
+          <p:nvPr>
+            <p:ph type="body" idx="1"/>
+          </p:nvPr>
+        </p:nvSpPr>
+        <p:spPr/>
+        <p:txBody>
+          <a:bodyPr/>
+          <a:lstStyle/>
+          <a:p>
+            <a:r>
+              <a:rPr lang="en-US" dirty="0"/>
+              <a:t>Pattern: cross. Style profile: stylish. Inputs combined into a result using a simple plus/equal grammar.
+Slide 12: 数式: 複数要素を成果へつなげる
+cross-visual: 数式 (cross) schematic sample
+cross-visual long description: 数式 (cross) のサンプルです。Inputs combined into a result using a simple plus/equal grammar. pptcreater の安全なschematicプリセットで生成しています。</a:t>
+            </a:r>
+            <a:endParaRPr lang="en-US" dirty="0"/>
+          </a:p>
+        </p:txBody>
+      </p:sp>
+      <p:sp>
+        <p:nvSpPr>
+          <p:cNvPr id="4" name="Slide Number Placeholder 3"/>
+          <p:cNvSpPr>
+            <a:spLocks noGrp="1"/>
+          </p:cNvSpPr>
+          <p:nvPr>
+            <p:ph type="sldNum" sz="quarter" idx="10"/>
+          </p:nvPr>
+        </p:nvSpPr>
+        <p:spPr/>
+        <p:txBody>
+          <a:bodyPr/>
+          <a:lstStyle/>
+          <a:p>
+            <a:fld id="{F7021451-1387-4CA6-816F-3879F97B5CBC}" type="slidenum">
+              <a:rPr lang="en-US"/>
+              <a:t>12</a:t>
+            </a:fld>
+            <a:endParaRPr lang="en-US"/>
+          </a:p>
+        </p:txBody>
+      </p:sp>
+    </p:spTree>
+    <p:extLst>
+      <p:ext uri="{BB962C8B-B14F-4D97-AF65-F5344CB8AC3E}">
+        <p14:creationId xmlns:p14="http://schemas.microsoft.com/office/powerpoint/2010/main" val="1024086991"/>
+      </p:ext>
+    </p:extLst>
+  </p:cSld>
+  <p:clrMapOvr>
+    <a:masterClrMapping/>
+  </p:clrMapOvr>
+</p:notes>
+</file>
+
+<file path=ppt/notesSlides/notesSlide13.xml><?xml version="1.0" encoding="utf-8"?>
+<p:notes xmlns:a="http://schemas.openxmlformats.org/drawingml/2006/main" xmlns:r="http://schemas.openxmlformats.org/officeDocument/2006/relationships" xmlns:p="http://schemas.openxmlformats.org/presentationml/2006/main">
+  <p:cSld>
+    <p:spTree>
+      <p:nvGrpSpPr>
+        <p:cNvPr id="1" name=""/>
+        <p:cNvGrpSpPr/>
+        <p:nvPr/>
+      </p:nvGrpSpPr>
+      <p:grpSpPr>
+        <a:xfrm>
+          <a:off x="0" y="0"/>
+          <a:ext cx="0" cy="0"/>
+          <a:chOff x="0" y="0"/>
+          <a:chExt cx="0" cy="0"/>
+        </a:xfrm>
+      </p:grpSpPr>
+      <p:sp>
+        <p:nvSpPr>
+          <p:cNvPr id="2" name="Slide Image Placeholder 1"/>
+          <p:cNvSpPr>
+            <a:spLocks noGrp="1" noRot="1" noChangeAspect="1"/>
+          </p:cNvSpPr>
+          <p:nvPr>
+            <p:ph type="sldImg"/>
+          </p:nvPr>
+        </p:nvSpPr>
+        <p:spPr/>
+      </p:sp>
+      <p:sp>
+        <p:nvSpPr>
+          <p:cNvPr id="3" name="Notes Placeholder 2"/>
+          <p:cNvSpPr>
+            <a:spLocks noGrp="1"/>
+          </p:cNvSpPr>
+          <p:nvPr>
+            <p:ph type="body" idx="1"/>
+          </p:nvPr>
+        </p:nvSpPr>
+        <p:spPr/>
+        <p:txBody>
+          <a:bodyPr/>
+          <a:lstStyle/>
+          <a:p>
+            <a:r>
+              <a:rPr lang="en-US" dirty="0"/>
+              <a:t>Pattern: set. Style profile: report. Grouped containers with optional member pills.
+Slide 13: グループ/集合: 要素をまとまりで見せる
+set-visual: グループ/集合 (set) schematic sample
+set-visual long description: グループ/集合 (set) のサンプルです。Grouped containers with optional member pills. pptcreater の安全なschematicプリセットで生成しています。</a:t>
+            </a:r>
+            <a:endParaRPr lang="en-US" dirty="0"/>
+          </a:p>
+        </p:txBody>
+      </p:sp>
+      <p:sp>
+        <p:nvSpPr>
+          <p:cNvPr id="4" name="Slide Number Placeholder 3"/>
+          <p:cNvSpPr>
+            <a:spLocks noGrp="1"/>
+          </p:cNvSpPr>
+          <p:nvPr>
+            <p:ph type="sldNum" sz="quarter" idx="10"/>
+          </p:nvPr>
+        </p:nvSpPr>
+        <p:spPr/>
+        <p:txBody>
+          <a:bodyPr/>
+          <a:lstStyle/>
+          <a:p>
+            <a:fld id="{F7021451-1387-4CA6-816F-3879F97B5CBC}" type="slidenum">
+              <a:rPr lang="en-US"/>
+              <a:t>13</a:t>
+            </a:fld>
+            <a:endParaRPr lang="en-US"/>
+          </a:p>
+        </p:txBody>
+      </p:sp>
+    </p:spTree>
+    <p:extLst>
+      <p:ext uri="{BB962C8B-B14F-4D97-AF65-F5344CB8AC3E}">
+        <p14:creationId xmlns:p14="http://schemas.microsoft.com/office/powerpoint/2010/main" val="1024086991"/>
+      </p:ext>
+    </p:extLst>
+  </p:cSld>
+  <p:clrMapOvr>
+    <a:masterClrMapping/>
+  </p:clrMapOvr>
+</p:notes>
+</file>
+
+<file path=ppt/notesSlides/notesSlide14.xml><?xml version="1.0" encoding="utf-8"?>
+<p:notes xmlns:a="http://schemas.openxmlformats.org/drawingml/2006/main" xmlns:r="http://schemas.openxmlformats.org/officeDocument/2006/relationships" xmlns:p="http://schemas.openxmlformats.org/presentationml/2006/main">
+  <p:cSld>
+    <p:spTree>
+      <p:nvGrpSpPr>
+        <p:cNvPr id="1" name=""/>
+        <p:cNvGrpSpPr/>
+        <p:nvPr/>
+      </p:nvGrpSpPr>
+      <p:grpSpPr>
+        <a:xfrm>
+          <a:off x="0" y="0"/>
+          <a:ext cx="0" cy="0"/>
+          <a:chOff x="0" y="0"/>
+          <a:chExt cx="0" cy="0"/>
+        </a:xfrm>
+      </p:grpSpPr>
+      <p:sp>
+        <p:nvSpPr>
+          <p:cNvPr id="2" name="Slide Image Placeholder 1"/>
+          <p:cNvSpPr>
+            <a:spLocks noGrp="1" noRot="1" noChangeAspect="1"/>
+          </p:cNvSpPr>
+          <p:nvPr>
+            <p:ph type="sldImg"/>
+          </p:nvPr>
+        </p:nvSpPr>
+        <p:spPr/>
+      </p:sp>
+      <p:sp>
+        <p:nvSpPr>
+          <p:cNvPr id="3" name="Notes Placeholder 2"/>
+          <p:cNvSpPr>
+            <a:spLocks noGrp="1"/>
+          </p:cNvSpPr>
+          <p:nvPr>
+            <p:ph type="body" idx="1"/>
+          </p:nvPr>
+        </p:nvSpPr>
+        <p:spPr/>
+        <p:txBody>
+          <a:bodyPr/>
+          <a:lstStyle/>
+          <a:p>
+            <a:r>
+              <a:rPr lang="en-US" dirty="0"/>
+              <a:t>Pattern: contrast. Style profile: presentation. Side-by-side option comparison with aligned rows and a center VS badge.
+Slide 14: 項目比較: 2案の違いを並べて見せる
+contrast-visual: 項目比較 (contrast) schematic sample
+contrast-visual long description: 項目比較 (contrast) のサンプルです。Side-by-side option comparison with aligned rows and a center VS badge. pptcreater の安全なschematicプリセットで生成しています。</a:t>
+            </a:r>
+            <a:endParaRPr lang="en-US" dirty="0"/>
+          </a:p>
+        </p:txBody>
+      </p:sp>
+      <p:sp>
+        <p:nvSpPr>
+          <p:cNvPr id="4" name="Slide Number Placeholder 3"/>
+          <p:cNvSpPr>
+            <a:spLocks noGrp="1"/>
+          </p:cNvSpPr>
+          <p:nvPr>
+            <p:ph type="sldNum" sz="quarter" idx="10"/>
+          </p:nvPr>
+        </p:nvSpPr>
+        <p:spPr/>
+        <p:txBody>
+          <a:bodyPr/>
+          <a:lstStyle/>
+          <a:p>
+            <a:fld id="{F7021451-1387-4CA6-816F-3879F97B5CBC}" type="slidenum">
+              <a:rPr lang="en-US"/>
+              <a:t>14</a:t>
+            </a:fld>
+            <a:endParaRPr lang="en-US"/>
+          </a:p>
+        </p:txBody>
+      </p:sp>
+    </p:spTree>
+    <p:extLst>
+      <p:ext uri="{BB962C8B-B14F-4D97-AF65-F5344CB8AC3E}">
+        <p14:creationId xmlns:p14="http://schemas.microsoft.com/office/powerpoint/2010/main" val="1024086991"/>
+      </p:ext>
+    </p:extLst>
+  </p:cSld>
+  <p:clrMapOvr>
+    <a:masterClrMapping/>
+  </p:clrMapOvr>
+</p:notes>
+</file>
+
+<file path=ppt/notesSlides/notesSlide15.xml><?xml version="1.0" encoding="utf-8"?>
+<p:notes xmlns:a="http://schemas.openxmlformats.org/drawingml/2006/main" xmlns:r="http://schemas.openxmlformats.org/officeDocument/2006/relationships" xmlns:p="http://schemas.openxmlformats.org/presentationml/2006/main">
+  <p:cSld>
+    <p:spTree>
+      <p:nvGrpSpPr>
+        <p:cNvPr id="1" name=""/>
+        <p:cNvGrpSpPr/>
+        <p:nvPr/>
+      </p:nvGrpSpPr>
+      <p:grpSpPr>
+        <a:xfrm>
+          <a:off x="0" y="0"/>
+          <a:ext cx="0" cy="0"/>
+          <a:chOff x="0" y="0"/>
+          <a:chExt cx="0" cy="0"/>
+        </a:xfrm>
+      </p:grpSpPr>
+      <p:sp>
+        <p:nvSpPr>
+          <p:cNvPr id="2" name="Slide Image Placeholder 1"/>
+          <p:cNvSpPr>
+            <a:spLocks noGrp="1" noRot="1" noChangeAspect="1"/>
+          </p:cNvSpPr>
+          <p:nvPr>
+            <p:ph type="sldImg"/>
+          </p:nvPr>
+        </p:nvSpPr>
+        <p:spPr/>
+      </p:sp>
+      <p:sp>
+        <p:nvSpPr>
+          <p:cNvPr id="3" name="Notes Placeholder 2"/>
+          <p:cNvSpPr>
+            <a:spLocks noGrp="1"/>
+          </p:cNvSpPr>
+          <p:nvPr>
+            <p:ph type="body" idx="1"/>
+          </p:nvPr>
+        </p:nvSpPr>
+        <p:spPr/>
+        <p:txBody>
+          <a:bodyPr/>
+          <a:lstStyle/>
+          <a:p>
+            <a:r>
+              <a:rPr lang="en-US" dirty="0"/>
+              <a:t>Pattern: scale-contrast. Style profile: technical. Relative-size bubbles based on parsed numeric values.
+Slide 15: 規模比較: 数値差を面積で直感化する
+scale-contrast-visual: 規模比較 (scale-contrast) schematic sample
+scale-contrast-visual long description: 規模比較 (scale-contrast) のサンプルです。Relative-size bubbles based on parsed numeric values. pptcreater の安全なschematicプリセットで生成しています。</a:t>
+            </a:r>
+            <a:endParaRPr lang="en-US" dirty="0"/>
+          </a:p>
+        </p:txBody>
+      </p:sp>
+      <p:sp>
+        <p:nvSpPr>
+          <p:cNvPr id="4" name="Slide Number Placeholder 3"/>
+          <p:cNvSpPr>
+            <a:spLocks noGrp="1"/>
+          </p:cNvSpPr>
+          <p:nvPr>
+            <p:ph type="sldNum" sz="quarter" idx="10"/>
+          </p:nvPr>
+        </p:nvSpPr>
+        <p:spPr/>
+        <p:txBody>
+          <a:bodyPr/>
+          <a:lstStyle/>
+          <a:p>
+            <a:fld id="{F7021451-1387-4CA6-816F-3879F97B5CBC}" type="slidenum">
+              <a:rPr lang="en-US"/>
+              <a:t>15</a:t>
+            </a:fld>
+            <a:endParaRPr lang="en-US"/>
+          </a:p>
+        </p:txBody>
+      </p:sp>
+    </p:spTree>
+    <p:extLst>
+      <p:ext uri="{BB962C8B-B14F-4D97-AF65-F5344CB8AC3E}">
+        <p14:creationId xmlns:p14="http://schemas.microsoft.com/office/powerpoint/2010/main" val="1024086991"/>
+      </p:ext>
+    </p:extLst>
+  </p:cSld>
+  <p:clrMapOvr>
+    <a:masterClrMapping/>
+  </p:clrMapOvr>
+</p:notes>
+</file>
+
+<file path=ppt/notesSlides/notesSlide16.xml><?xml version="1.0" encoding="utf-8"?>
+<p:notes xmlns:a="http://schemas.openxmlformats.org/drawingml/2006/main" xmlns:r="http://schemas.openxmlformats.org/officeDocument/2006/relationships" xmlns:p="http://schemas.openxmlformats.org/presentationml/2006/main">
+  <p:cSld>
+    <p:spTree>
+      <p:nvGrpSpPr>
+        <p:cNvPr id="1" name=""/>
+        <p:cNvGrpSpPr/>
+        <p:nvPr/>
+      </p:nvGrpSpPr>
+      <p:grpSpPr>
+        <a:xfrm>
+          <a:off x="0" y="0"/>
+          <a:ext cx="0" cy="0"/>
+          <a:chOff x="0" y="0"/>
+          <a:chExt cx="0" cy="0"/>
+        </a:xfrm>
+      </p:grpSpPr>
+      <p:sp>
+        <p:nvSpPr>
+          <p:cNvPr id="2" name="Slide Image Placeholder 1"/>
+          <p:cNvSpPr>
+            <a:spLocks noGrp="1" noRot="1" noChangeAspect="1"/>
+          </p:cNvSpPr>
+          <p:nvPr>
+            <p:ph type="sldImg"/>
+          </p:nvPr>
+        </p:nvSpPr>
+        <p:spPr/>
+      </p:sp>
+      <p:sp>
+        <p:nvSpPr>
+          <p:cNvPr id="3" name="Notes Placeholder 2"/>
+          <p:cNvSpPr>
+            <a:spLocks noGrp="1"/>
+          </p:cNvSpPr>
+          <p:nvPr>
+            <p:ph type="body" idx="1"/>
+          </p:nvPr>
+        </p:nvSpPr>
+        <p:spPr/>
+        <p:txBody>
+          <a:bodyPr/>
+          <a:lstStyle/>
+          <a:p>
+            <a:r>
+              <a:rPr lang="en-US" dirty="0"/>
+              <a:t>Pattern: grow. Style profile: minimal. Concentric market-size or scope analysis.
+Slide 16: 規模分析: TAM/SAM/SOMを同心円で示す
+grow-visual: 規模分析 (grow) schematic sample
+grow-visual long description: 規模分析 (grow) のサンプルです。Concentric market-size or scope analysis. pptcreater の安全なschematicプリセットで生成しています。</a:t>
+            </a:r>
+            <a:endParaRPr lang="en-US" dirty="0"/>
+          </a:p>
+        </p:txBody>
+      </p:sp>
+      <p:sp>
+        <p:nvSpPr>
+          <p:cNvPr id="4" name="Slide Number Placeholder 3"/>
+          <p:cNvSpPr>
+            <a:spLocks noGrp="1"/>
+          </p:cNvSpPr>
+          <p:nvPr>
+            <p:ph type="sldNum" sz="quarter" idx="10"/>
+          </p:nvPr>
+        </p:nvSpPr>
+        <p:spPr/>
+        <p:txBody>
+          <a:bodyPr/>
+          <a:lstStyle/>
+          <a:p>
+            <a:fld id="{F7021451-1387-4CA6-816F-3879F97B5CBC}" type="slidenum">
+              <a:rPr lang="en-US"/>
+              <a:t>16</a:t>
+            </a:fld>
+            <a:endParaRPr lang="en-US"/>
+          </a:p>
+        </p:txBody>
+      </p:sp>
+    </p:spTree>
+    <p:extLst>
+      <p:ext uri="{BB962C8B-B14F-4D97-AF65-F5344CB8AC3E}">
+        <p14:creationId xmlns:p14="http://schemas.microsoft.com/office/powerpoint/2010/main" val="1024086991"/>
+      </p:ext>
+    </p:extLst>
+  </p:cSld>
+  <p:clrMapOvr>
+    <a:masterClrMapping/>
+  </p:clrMapOvr>
+</p:notes>
+</file>
+
+<file path=ppt/notesSlides/notesSlide17.xml><?xml version="1.0" encoding="utf-8"?>
+<p:notes xmlns:a="http://schemas.openxmlformats.org/drawingml/2006/main" xmlns:r="http://schemas.openxmlformats.org/officeDocument/2006/relationships" xmlns:p="http://schemas.openxmlformats.org/presentationml/2006/main">
+  <p:cSld>
+    <p:spTree>
+      <p:nvGrpSpPr>
+        <p:cNvPr id="1" name=""/>
+        <p:cNvGrpSpPr/>
+        <p:nvPr/>
+      </p:nvGrpSpPr>
+      <p:grpSpPr>
+        <a:xfrm>
+          <a:off x="0" y="0"/>
+          <a:ext cx="0" cy="0"/>
+          <a:chOff x="0" y="0"/>
+          <a:chExt cx="0" cy="0"/>
+        </a:xfrm>
+      </p:grpSpPr>
+      <p:sp>
+        <p:nvSpPr>
+          <p:cNvPr id="2" name="Slide Image Placeholder 1"/>
+          <p:cNvSpPr>
+            <a:spLocks noGrp="1" noRot="1" noChangeAspect="1"/>
+          </p:cNvSpPr>
+          <p:nvPr>
+            <p:ph type="sldImg"/>
+          </p:nvPr>
+        </p:nvSpPr>
+        <p:spPr/>
+      </p:sp>
+      <p:sp>
+        <p:nvSpPr>
+          <p:cNvPr id="3" name="Notes Placeholder 2"/>
+          <p:cNvSpPr>
+            <a:spLocks noGrp="1"/>
+          </p:cNvSpPr>
+          <p:nvPr>
+            <p:ph type="body" idx="1"/>
+          </p:nvPr>
+        </p:nvSpPr>
+        <p:spPr/>
+        <p:txBody>
+          <a:bodyPr/>
+          <a:lstStyle/>
+          <a:p>
+            <a:r>
+              <a:rPr lang="en-US" dirty="0"/>
+              <a:t>Pattern: layer. Style profile: stylish. Stacked architecture, governance, or responsibility layers.
+Slide 17: レイヤー構造: アーキテクチャを積層で説明する
+layer-visual: レイヤー構造 (layer) schematic sample
+layer-visual long description: レイヤー構造 (layer) のサンプルです。Stacked architecture, governance, or responsibility layers. pptcreater の安全なschematicプリセットで生成しています。</a:t>
+            </a:r>
+            <a:endParaRPr lang="en-US" dirty="0"/>
+          </a:p>
+        </p:txBody>
+      </p:sp>
+      <p:sp>
+        <p:nvSpPr>
+          <p:cNvPr id="4" name="Slide Number Placeholder 3"/>
+          <p:cNvSpPr>
+            <a:spLocks noGrp="1"/>
+          </p:cNvSpPr>
+          <p:nvPr>
+            <p:ph type="sldNum" sz="quarter" idx="10"/>
+          </p:nvPr>
+        </p:nvSpPr>
+        <p:spPr/>
+        <p:txBody>
+          <a:bodyPr/>
+          <a:lstStyle/>
+          <a:p>
+            <a:fld id="{F7021451-1387-4CA6-816F-3879F97B5CBC}" type="slidenum">
+              <a:rPr lang="en-US"/>
+              <a:t>17</a:t>
+            </a:fld>
+            <a:endParaRPr lang="en-US"/>
+          </a:p>
+        </p:txBody>
+      </p:sp>
+    </p:spTree>
+    <p:extLst>
+      <p:ext uri="{BB962C8B-B14F-4D97-AF65-F5344CB8AC3E}">
+        <p14:creationId xmlns:p14="http://schemas.microsoft.com/office/powerpoint/2010/main" val="1024086991"/>
+      </p:ext>
+    </p:extLst>
+  </p:cSld>
+  <p:clrMapOvr>
+    <a:masterClrMapping/>
+  </p:clrMapOvr>
+</p:notes>
+</file>
+
+<file path=ppt/notesSlides/notesSlide18.xml><?xml version="1.0" encoding="utf-8"?>
+<p:notes xmlns:a="http://schemas.openxmlformats.org/drawingml/2006/main" xmlns:r="http://schemas.openxmlformats.org/officeDocument/2006/relationships" xmlns:p="http://schemas.openxmlformats.org/presentationml/2006/main">
+  <p:cSld>
+    <p:spTree>
+      <p:nvGrpSpPr>
+        <p:cNvPr id="1" name=""/>
+        <p:cNvGrpSpPr/>
+        <p:nvPr/>
+      </p:nvGrpSpPr>
+      <p:grpSpPr>
+        <a:xfrm>
+          <a:off x="0" y="0"/>
+          <a:ext cx="0" cy="0"/>
+          <a:chOff x="0" y="0"/>
+          <a:chExt cx="0" cy="0"/>
+        </a:xfrm>
+      </p:grpSpPr>
+      <p:sp>
+        <p:nvSpPr>
+          <p:cNvPr id="2" name="Slide Image Placeholder 1"/>
+          <p:cNvSpPr>
+            <a:spLocks noGrp="1" noRot="1" noChangeAspect="1"/>
+          </p:cNvSpPr>
+          <p:nvPr>
+            <p:ph type="sldImg"/>
+          </p:nvPr>
+        </p:nvSpPr>
+        <p:spPr/>
+      </p:sp>
+      <p:sp>
+        <p:nvSpPr>
+          <p:cNvPr id="3" name="Notes Placeholder 2"/>
+          <p:cNvSpPr>
+            <a:spLocks noGrp="1"/>
+          </p:cNvSpPr>
+          <p:nvPr>
+            <p:ph type="body" idx="1"/>
+          </p:nvPr>
+        </p:nvSpPr>
+        <p:spPr/>
+        <p:txBody>
+          <a:bodyPr/>
+          <a:lstStyle/>
+          <a:p>
+            <a:r>
+              <a:rPr lang="en-US" dirty="0"/>
+              <a:t>Pattern: triangle. Style profile: report. Pyramid levels showing foundation to apex.
+Slide 18: トライアングル: 基盤から頂点までを示す
+triangle-visual: トライアングル (triangle) schematic sample
+triangle-visual long description: トライアングル (triangle) のサンプルです。Pyramid levels showing foundation to apex. pptcreater の安全なschematicプリセットで生成しています。</a:t>
+            </a:r>
+            <a:endParaRPr lang="en-US" dirty="0"/>
+          </a:p>
+        </p:txBody>
+      </p:sp>
+      <p:sp>
+        <p:nvSpPr>
+          <p:cNvPr id="4" name="Slide Number Placeholder 3"/>
+          <p:cNvSpPr>
+            <a:spLocks noGrp="1"/>
+          </p:cNvSpPr>
+          <p:nvPr>
+            <p:ph type="sldNum" sz="quarter" idx="10"/>
+          </p:nvPr>
+        </p:nvSpPr>
+        <p:spPr/>
+        <p:txBody>
+          <a:bodyPr/>
+          <a:lstStyle/>
+          <a:p>
+            <a:fld id="{F7021451-1387-4CA6-816F-3879F97B5CBC}" type="slidenum">
+              <a:rPr lang="en-US"/>
+              <a:t>18</a:t>
+            </a:fld>
+            <a:endParaRPr lang="en-US"/>
+          </a:p>
+        </p:txBody>
+      </p:sp>
+    </p:spTree>
+    <p:extLst>
+      <p:ext uri="{BB962C8B-B14F-4D97-AF65-F5344CB8AC3E}">
+        <p14:creationId xmlns:p14="http://schemas.microsoft.com/office/powerpoint/2010/main" val="1024086991"/>
+      </p:ext>
+    </p:extLst>
+  </p:cSld>
+  <p:clrMapOvr>
+    <a:masterClrMapping/>
+  </p:clrMapOvr>
+</p:notes>
+</file>
+
+<file path=ppt/notesSlides/notesSlide19.xml><?xml version="1.0" encoding="utf-8"?>
+<p:notes xmlns:a="http://schemas.openxmlformats.org/drawingml/2006/main" xmlns:r="http://schemas.openxmlformats.org/officeDocument/2006/relationships" xmlns:p="http://schemas.openxmlformats.org/presentationml/2006/main">
+  <p:cSld>
+    <p:spTree>
+      <p:nvGrpSpPr>
+        <p:cNvPr id="1" name=""/>
+        <p:cNvGrpSpPr/>
+        <p:nvPr/>
+      </p:nvGrpSpPr>
+      <p:grpSpPr>
+        <a:xfrm>
+          <a:off x="0" y="0"/>
+          <a:ext cx="0" cy="0"/>
+          <a:chOff x="0" y="0"/>
+          <a:chExt cx="0" cy="0"/>
+        </a:xfrm>
+      </p:grpSpPr>
+      <p:sp>
+        <p:nvSpPr>
+          <p:cNvPr id="2" name="Slide Image Placeholder 1"/>
+          <p:cNvSpPr>
+            <a:spLocks noGrp="1" noRot="1" noChangeAspect="1"/>
+          </p:cNvSpPr>
+          <p:nvPr>
+            <p:ph type="sldImg"/>
+          </p:nvPr>
+        </p:nvSpPr>
+        <p:spPr/>
+      </p:sp>
+      <p:sp>
+        <p:nvSpPr>
+          <p:cNvPr id="3" name="Notes Placeholder 2"/>
+          <p:cNvSpPr>
+            <a:spLocks noGrp="1"/>
+          </p:cNvSpPr>
+          <p:nvPr>
+            <p:ph type="body" idx="1"/>
+          </p:nvPr>
+        </p:nvSpPr>
+        <p:spPr/>
+        <p:txBody>
+          <a:bodyPr/>
+          <a:lstStyle/>
+          <a:p>
+            <a:r>
+              <a:rPr lang="en-US" dirty="0"/>
+              <a:t>Pattern: step. Style profile: presentation. Ascending maturity, roadmap, or progression steps.
+Slide 19: 階段: 成熟度やロードマップを段階で示す
+step-visual: 階段/ステップ (step) schematic sample
+step-visual long description: 階段/ステップ (step) のサンプルです。Ascending maturity, roadmap, or progression steps. pptcreater の安全なschematicプリセットで生成しています。</a:t>
+            </a:r>
+            <a:endParaRPr lang="en-US" dirty="0"/>
+          </a:p>
+        </p:txBody>
+      </p:sp>
+      <p:sp>
+        <p:nvSpPr>
+          <p:cNvPr id="4" name="Slide Number Placeholder 3"/>
+          <p:cNvSpPr>
+            <a:spLocks noGrp="1"/>
+          </p:cNvSpPr>
+          <p:nvPr>
+            <p:ph type="sldNum" sz="quarter" idx="10"/>
+          </p:nvPr>
+        </p:nvSpPr>
+        <p:spPr/>
+        <p:txBody>
+          <a:bodyPr/>
+          <a:lstStyle/>
+          <a:p>
+            <a:fld id="{F7021451-1387-4CA6-816F-3879F97B5CBC}" type="slidenum">
+              <a:rPr lang="en-US"/>
+              <a:t>19</a:t>
+            </a:fld>
+            <a:endParaRPr lang="en-US"/>
+          </a:p>
+        </p:txBody>
+      </p:sp>
+    </p:spTree>
+    <p:extLst>
+      <p:ext uri="{BB962C8B-B14F-4D97-AF65-F5344CB8AC3E}">
+        <p14:creationId xmlns:p14="http://schemas.microsoft.com/office/powerpoint/2010/main" val="1024086991"/>
+      </p:ext>
+    </p:extLst>
+  </p:cSld>
+  <p:clrMapOvr>
+    <a:masterClrMapping/>
+  </p:clrMapOvr>
+</p:notes>
+</file>
+
 <file path=ppt/notesSlides/notesSlide2.xml><?xml version="1.0" encoding="utf-8"?>
 <p:notes xmlns:a="http://schemas.openxmlformats.org/drawingml/2006/main" xmlns:r="http://schemas.openxmlformats.org/officeDocument/2006/relationships" xmlns:p="http://schemas.openxmlformats.org/presentationml/2006/main">
   <p:cSld>
@@ -597,10 +1528,10 @@
           <a:p>
             <a:r>
               <a:rPr lang="en-US" dirty="0"/>
-              <a:t>generate_schematic で生成した安全な図解プリセットの例です。
-Slide 2: 表: 論点と判断材料をそろえる
-table-visual: table schematic sample
-table-visual long description: table schematic sample generated from a safe preset to demonstrate Slideland-inspired layouts in pptcreater.</a:t>
+              <a:t>Pattern: tree. Style profile: stylish. Hierarchy with a root concept and child branches.
+Slide 2: ツリー: 複雑な情報を階層で整理する
+tree-visual: ツリー (tree) schematic sample
+tree-visual long description: ツリー (tree) のサンプルです。Hierarchy with a root concept and child branches. pptcreater の安全なschematicプリセットで生成しています。</a:t>
             </a:r>
             <a:endParaRPr lang="en-US" dirty="0"/>
           </a:p>
@@ -642,6 +1573,642 @@
 </p:notes>
 </file>
 
+<file path=ppt/notesSlides/notesSlide20.xml><?xml version="1.0" encoding="utf-8"?>
+<p:notes xmlns:a="http://schemas.openxmlformats.org/drawingml/2006/main" xmlns:r="http://schemas.openxmlformats.org/officeDocument/2006/relationships" xmlns:p="http://schemas.openxmlformats.org/presentationml/2006/main">
+  <p:cSld>
+    <p:spTree>
+      <p:nvGrpSpPr>
+        <p:cNvPr id="1" name=""/>
+        <p:cNvGrpSpPr/>
+        <p:nvPr/>
+      </p:nvGrpSpPr>
+      <p:grpSpPr>
+        <a:xfrm>
+          <a:off x="0" y="0"/>
+          <a:ext cx="0" cy="0"/>
+          <a:chOff x="0" y="0"/>
+          <a:chExt cx="0" cy="0"/>
+        </a:xfrm>
+      </p:grpSpPr>
+      <p:sp>
+        <p:nvSpPr>
+          <p:cNvPr id="2" name="Slide Image Placeholder 1"/>
+          <p:cNvSpPr>
+            <a:spLocks noGrp="1" noRot="1" noChangeAspect="1"/>
+          </p:cNvSpPr>
+          <p:nvPr>
+            <p:ph type="sldImg"/>
+          </p:nvPr>
+        </p:nvSpPr>
+        <p:spPr/>
+      </p:sp>
+      <p:sp>
+        <p:nvSpPr>
+          <p:cNvPr id="3" name="Notes Placeholder 2"/>
+          <p:cNvSpPr>
+            <a:spLocks noGrp="1"/>
+          </p:cNvSpPr>
+          <p:nvPr>
+            <p:ph type="body" idx="1"/>
+          </p:nvPr>
+        </p:nvSpPr>
+        <p:spPr/>
+        <p:txBody>
+          <a:bodyPr/>
+          <a:lstStyle/>
+          <a:p>
+            <a:r>
+              <a:rPr lang="en-US" dirty="0"/>
+              <a:t>Pattern: gantt. Style profile: technical. Simple task-by-period schedule with safe staggered bars.
+Slide 20: ガントチャート: 作業と期間を同じ面で見る
+gantt-visual: ガントチャート (gantt) schematic sample
+gantt-visual long description: ガントチャート (gantt) のサンプルです。Simple task-by-period schedule with safe staggered bars. pptcreater の安全なschematicプリセットで生成しています。</a:t>
+            </a:r>
+            <a:endParaRPr lang="en-US" dirty="0"/>
+          </a:p>
+        </p:txBody>
+      </p:sp>
+      <p:sp>
+        <p:nvSpPr>
+          <p:cNvPr id="4" name="Slide Number Placeholder 3"/>
+          <p:cNvSpPr>
+            <a:spLocks noGrp="1"/>
+          </p:cNvSpPr>
+          <p:nvPr>
+            <p:ph type="sldNum" sz="quarter" idx="10"/>
+          </p:nvPr>
+        </p:nvSpPr>
+        <p:spPr/>
+        <p:txBody>
+          <a:bodyPr/>
+          <a:lstStyle/>
+          <a:p>
+            <a:fld id="{F7021451-1387-4CA6-816F-3879F97B5CBC}" type="slidenum">
+              <a:rPr lang="en-US"/>
+              <a:t>20</a:t>
+            </a:fld>
+            <a:endParaRPr lang="en-US"/>
+          </a:p>
+        </p:txBody>
+      </p:sp>
+    </p:spTree>
+    <p:extLst>
+      <p:ext uri="{BB962C8B-B14F-4D97-AF65-F5344CB8AC3E}">
+        <p14:creationId xmlns:p14="http://schemas.microsoft.com/office/powerpoint/2010/main" val="1024086991"/>
+      </p:ext>
+    </p:extLst>
+  </p:cSld>
+  <p:clrMapOvr>
+    <a:masterClrMapping/>
+  </p:clrMapOvr>
+</p:notes>
+</file>
+
+<file path=ppt/notesSlides/notesSlide21.xml><?xml version="1.0" encoding="utf-8"?>
+<p:notes xmlns:a="http://schemas.openxmlformats.org/drawingml/2006/main" xmlns:r="http://schemas.openxmlformats.org/officeDocument/2006/relationships" xmlns:p="http://schemas.openxmlformats.org/presentationml/2006/main">
+  <p:cSld>
+    <p:spTree>
+      <p:nvGrpSpPr>
+        <p:cNvPr id="1" name=""/>
+        <p:cNvGrpSpPr/>
+        <p:nvPr/>
+      </p:nvGrpSpPr>
+      <p:grpSpPr>
+        <a:xfrm>
+          <a:off x="0" y="0"/>
+          <a:ext cx="0" cy="0"/>
+          <a:chOff x="0" y="0"/>
+          <a:chExt cx="0" cy="0"/>
+        </a:xfrm>
+      </p:grpSpPr>
+      <p:sp>
+        <p:nvSpPr>
+          <p:cNvPr id="2" name="Slide Image Placeholder 1"/>
+          <p:cNvSpPr>
+            <a:spLocks noGrp="1" noRot="1" noChangeAspect="1"/>
+          </p:cNvSpPr>
+          <p:nvPr>
+            <p:ph type="sldImg"/>
+          </p:nvPr>
+        </p:nvSpPr>
+        <p:spPr/>
+      </p:sp>
+      <p:sp>
+        <p:nvSpPr>
+          <p:cNvPr id="3" name="Notes Placeholder 2"/>
+          <p:cNvSpPr>
+            <a:spLocks noGrp="1"/>
+          </p:cNvSpPr>
+          <p:nvPr>
+            <p:ph type="body" idx="1"/>
+          </p:nvPr>
+        </p:nvSpPr>
+        <p:spPr/>
+        <p:txBody>
+          <a:bodyPr/>
+          <a:lstStyle/>
+          <a:p>
+            <a:r>
+              <a:rPr lang="en-US" dirty="0"/>
+              <a:t>Pattern: ranking. Style profile: minimal. Ordered list with rank badges and value bars.
+Slide 21: ランキング: 優先順位と差を同時に見せる
+ranking-visual: ランキング (ranking) schematic sample
+ranking-visual long description: ランキング (ranking) のサンプルです。Ordered list with rank badges and value bars. pptcreater の安全なschematicプリセットで生成しています。</a:t>
+            </a:r>
+            <a:endParaRPr lang="en-US" dirty="0"/>
+          </a:p>
+        </p:txBody>
+      </p:sp>
+      <p:sp>
+        <p:nvSpPr>
+          <p:cNvPr id="4" name="Slide Number Placeholder 3"/>
+          <p:cNvSpPr>
+            <a:spLocks noGrp="1"/>
+          </p:cNvSpPr>
+          <p:nvPr>
+            <p:ph type="sldNum" sz="quarter" idx="10"/>
+          </p:nvPr>
+        </p:nvSpPr>
+        <p:spPr/>
+        <p:txBody>
+          <a:bodyPr/>
+          <a:lstStyle/>
+          <a:p>
+            <a:fld id="{F7021451-1387-4CA6-816F-3879F97B5CBC}" type="slidenum">
+              <a:rPr lang="en-US"/>
+              <a:t>21</a:t>
+            </a:fld>
+            <a:endParaRPr lang="en-US"/>
+          </a:p>
+        </p:txBody>
+      </p:sp>
+    </p:spTree>
+    <p:extLst>
+      <p:ext uri="{BB962C8B-B14F-4D97-AF65-F5344CB8AC3E}">
+        <p14:creationId xmlns:p14="http://schemas.microsoft.com/office/powerpoint/2010/main" val="1024086991"/>
+      </p:ext>
+    </p:extLst>
+  </p:cSld>
+  <p:clrMapOvr>
+    <a:masterClrMapping/>
+  </p:clrMapOvr>
+</p:notes>
+</file>
+
+<file path=ppt/notesSlides/notesSlide22.xml><?xml version="1.0" encoding="utf-8"?>
+<p:notes xmlns:a="http://schemas.openxmlformats.org/drawingml/2006/main" xmlns:r="http://schemas.openxmlformats.org/officeDocument/2006/relationships" xmlns:p="http://schemas.openxmlformats.org/presentationml/2006/main">
+  <p:cSld>
+    <p:spTree>
+      <p:nvGrpSpPr>
+        <p:cNvPr id="1" name=""/>
+        <p:cNvGrpSpPr/>
+        <p:nvPr/>
+      </p:nvGrpSpPr>
+      <p:grpSpPr>
+        <a:xfrm>
+          <a:off x="0" y="0"/>
+          <a:ext cx="0" cy="0"/>
+          <a:chOff x="0" y="0"/>
+          <a:chExt cx="0" cy="0"/>
+        </a:xfrm>
+      </p:grpSpPr>
+      <p:sp>
+        <p:nvSpPr>
+          <p:cNvPr id="2" name="Slide Image Placeholder 1"/>
+          <p:cNvSpPr>
+            <a:spLocks noGrp="1" noRot="1" noChangeAspect="1"/>
+          </p:cNvSpPr>
+          <p:nvPr>
+            <p:ph type="sldImg"/>
+          </p:nvPr>
+        </p:nvSpPr>
+        <p:spPr/>
+      </p:sp>
+      <p:sp>
+        <p:nvSpPr>
+          <p:cNvPr id="3" name="Notes Placeholder 2"/>
+          <p:cNvSpPr>
+            <a:spLocks noGrp="1"/>
+          </p:cNvSpPr>
+          <p:nvPr>
+            <p:ph type="body" idx="1"/>
+          </p:nvPr>
+        </p:nvSpPr>
+        <p:spPr/>
+        <p:txBody>
+          <a:bodyPr/>
+          <a:lstStyle/>
+          <a:p>
+            <a:r>
+              <a:rPr lang="en-US" dirty="0"/>
+              <a:t>Pattern: list. Style profile: stylish. Readable vertical list with badges.
+Slide 22: 箇条書き縦: 重要項目を読みやすく並べる
+list-visual: 箇条書き縦 (list) schematic sample
+list-visual long description: 箇条書き縦 (list) のサンプルです。Readable vertical list with badges. pptcreater の安全なschematicプリセットで生成しています。</a:t>
+            </a:r>
+            <a:endParaRPr lang="en-US" dirty="0"/>
+          </a:p>
+        </p:txBody>
+      </p:sp>
+      <p:sp>
+        <p:nvSpPr>
+          <p:cNvPr id="4" name="Slide Number Placeholder 3"/>
+          <p:cNvSpPr>
+            <a:spLocks noGrp="1"/>
+          </p:cNvSpPr>
+          <p:nvPr>
+            <p:ph type="sldNum" sz="quarter" idx="10"/>
+          </p:nvPr>
+        </p:nvSpPr>
+        <p:spPr/>
+        <p:txBody>
+          <a:bodyPr/>
+          <a:lstStyle/>
+          <a:p>
+            <a:fld id="{F7021451-1387-4CA6-816F-3879F97B5CBC}" type="slidenum">
+              <a:rPr lang="en-US"/>
+              <a:t>22</a:t>
+            </a:fld>
+            <a:endParaRPr lang="en-US"/>
+          </a:p>
+        </p:txBody>
+      </p:sp>
+    </p:spTree>
+    <p:extLst>
+      <p:ext uri="{BB962C8B-B14F-4D97-AF65-F5344CB8AC3E}">
+        <p14:creationId xmlns:p14="http://schemas.microsoft.com/office/powerpoint/2010/main" val="1024086991"/>
+      </p:ext>
+    </p:extLst>
+  </p:cSld>
+  <p:clrMapOvr>
+    <a:masterClrMapping/>
+  </p:clrMapOvr>
+</p:notes>
+</file>
+
+<file path=ppt/notesSlides/notesSlide23.xml><?xml version="1.0" encoding="utf-8"?>
+<p:notes xmlns:a="http://schemas.openxmlformats.org/drawingml/2006/main" xmlns:r="http://schemas.openxmlformats.org/officeDocument/2006/relationships" xmlns:p="http://schemas.openxmlformats.org/presentationml/2006/main">
+  <p:cSld>
+    <p:spTree>
+      <p:nvGrpSpPr>
+        <p:cNvPr id="1" name=""/>
+        <p:cNvGrpSpPr/>
+        <p:nvPr/>
+      </p:nvGrpSpPr>
+      <p:grpSpPr>
+        <a:xfrm>
+          <a:off x="0" y="0"/>
+          <a:ext cx="0" cy="0"/>
+          <a:chOff x="0" y="0"/>
+          <a:chExt cx="0" cy="0"/>
+        </a:xfrm>
+      </p:grpSpPr>
+      <p:sp>
+        <p:nvSpPr>
+          <p:cNvPr id="2" name="Slide Image Placeholder 1"/>
+          <p:cNvSpPr>
+            <a:spLocks noGrp="1" noRot="1" noChangeAspect="1"/>
+          </p:cNvSpPr>
+          <p:nvPr>
+            <p:ph type="sldImg"/>
+          </p:nvPr>
+        </p:nvSpPr>
+        <p:spPr/>
+      </p:sp>
+      <p:sp>
+        <p:nvSpPr>
+          <p:cNvPr id="3" name="Notes Placeholder 2"/>
+          <p:cNvSpPr>
+            <a:spLocks noGrp="1"/>
+          </p:cNvSpPr>
+          <p:nvPr>
+            <p:ph type="body" idx="1"/>
+          </p:nvPr>
+        </p:nvSpPr>
+        <p:spPr/>
+        <p:txBody>
+          <a:bodyPr/>
+          <a:lstStyle/>
+          <a:p>
+            <a:r>
+              <a:rPr lang="en-US" dirty="0"/>
+              <a:t>Pattern: list-horizontal. Style profile: report. Horizontal card list for three or four key points.
+Slide 23: 箇条書き横: 3-4点をカードで見せる
+list-horizontal-visual: 箇条書き横 (list-horizontal) schematic sample
+list-horizontal-visual long description: 箇条書き横 (list-horizontal) のサンプルです。Horizontal card list for three or four key points. pptcreater の安全なschematicプリセットで生成しています。</a:t>
+            </a:r>
+            <a:endParaRPr lang="en-US" dirty="0"/>
+          </a:p>
+        </p:txBody>
+      </p:sp>
+      <p:sp>
+        <p:nvSpPr>
+          <p:cNvPr id="4" name="Slide Number Placeholder 3"/>
+          <p:cNvSpPr>
+            <a:spLocks noGrp="1"/>
+          </p:cNvSpPr>
+          <p:nvPr>
+            <p:ph type="sldNum" sz="quarter" idx="10"/>
+          </p:nvPr>
+        </p:nvSpPr>
+        <p:spPr/>
+        <p:txBody>
+          <a:bodyPr/>
+          <a:lstStyle/>
+          <a:p>
+            <a:fld id="{F7021451-1387-4CA6-816F-3879F97B5CBC}" type="slidenum">
+              <a:rPr lang="en-US"/>
+              <a:t>23</a:t>
+            </a:fld>
+            <a:endParaRPr lang="en-US"/>
+          </a:p>
+        </p:txBody>
+      </p:sp>
+    </p:spTree>
+    <p:extLst>
+      <p:ext uri="{BB962C8B-B14F-4D97-AF65-F5344CB8AC3E}">
+        <p14:creationId xmlns:p14="http://schemas.microsoft.com/office/powerpoint/2010/main" val="1024086991"/>
+      </p:ext>
+    </p:extLst>
+  </p:cSld>
+  <p:clrMapOvr>
+    <a:masterClrMapping/>
+  </p:clrMapOvr>
+</p:notes>
+</file>
+
+<file path=ppt/notesSlides/notesSlide24.xml><?xml version="1.0" encoding="utf-8"?>
+<p:notes xmlns:a="http://schemas.openxmlformats.org/drawingml/2006/main" xmlns:r="http://schemas.openxmlformats.org/officeDocument/2006/relationships" xmlns:p="http://schemas.openxmlformats.org/presentationml/2006/main">
+  <p:cSld>
+    <p:spTree>
+      <p:nvGrpSpPr>
+        <p:cNvPr id="1" name=""/>
+        <p:cNvGrpSpPr/>
+        <p:nvPr/>
+      </p:nvGrpSpPr>
+      <p:grpSpPr>
+        <a:xfrm>
+          <a:off x="0" y="0"/>
+          <a:ext cx="0" cy="0"/>
+          <a:chOff x="0" y="0"/>
+          <a:chExt cx="0" cy="0"/>
+        </a:xfrm>
+      </p:grpSpPr>
+      <p:sp>
+        <p:nvSpPr>
+          <p:cNvPr id="2" name="Slide Image Placeholder 1"/>
+          <p:cNvSpPr>
+            <a:spLocks noGrp="1" noRot="1" noChangeAspect="1"/>
+          </p:cNvSpPr>
+          <p:nvPr>
+            <p:ph type="sldImg"/>
+          </p:nvPr>
+        </p:nvSpPr>
+        <p:spPr/>
+      </p:sp>
+      <p:sp>
+        <p:nvSpPr>
+          <p:cNvPr id="3" name="Notes Placeholder 2"/>
+          <p:cNvSpPr>
+            <a:spLocks noGrp="1"/>
+          </p:cNvSpPr>
+          <p:nvPr>
+            <p:ph type="body" idx="1"/>
+          </p:nvPr>
+        </p:nvSpPr>
+        <p:spPr/>
+        <p:txBody>
+          <a:bodyPr/>
+          <a:lstStyle/>
+          <a:p>
+            <a:r>
+              <a:rPr lang="en-US" dirty="0"/>
+              <a:t>Pattern: list-enumeration. Style profile: presentation. Numbered vertical list for ordered checkpoints.
+Slide 24: 箇条書き羅列: 手順やチェックを番号で示す
+list-enumeration-visual: 箇条書き羅列 (list-enumeration) schematic sample
+list-enumeration-visual long description: 箇条書き羅列 (list-enumeration) のサンプルです。Numbered vertical list for ordered checkpoints. pptcreater の安全なschematicプリセットで生成しています。</a:t>
+            </a:r>
+            <a:endParaRPr lang="en-US" dirty="0"/>
+          </a:p>
+        </p:txBody>
+      </p:sp>
+      <p:sp>
+        <p:nvSpPr>
+          <p:cNvPr id="4" name="Slide Number Placeholder 3"/>
+          <p:cNvSpPr>
+            <a:spLocks noGrp="1"/>
+          </p:cNvSpPr>
+          <p:nvPr>
+            <p:ph type="sldNum" sz="quarter" idx="10"/>
+          </p:nvPr>
+        </p:nvSpPr>
+        <p:spPr/>
+        <p:txBody>
+          <a:bodyPr/>
+          <a:lstStyle/>
+          <a:p>
+            <a:fld id="{F7021451-1387-4CA6-816F-3879F97B5CBC}" type="slidenum">
+              <a:rPr lang="en-US"/>
+              <a:t>24</a:t>
+            </a:fld>
+            <a:endParaRPr lang="en-US"/>
+          </a:p>
+        </p:txBody>
+      </p:sp>
+    </p:spTree>
+    <p:extLst>
+      <p:ext uri="{BB962C8B-B14F-4D97-AF65-F5344CB8AC3E}">
+        <p14:creationId xmlns:p14="http://schemas.microsoft.com/office/powerpoint/2010/main" val="1024086991"/>
+      </p:ext>
+    </p:extLst>
+  </p:cSld>
+  <p:clrMapOvr>
+    <a:masterClrMapping/>
+  </p:clrMapOvr>
+</p:notes>
+</file>
+
+<file path=ppt/notesSlides/notesSlide25.xml><?xml version="1.0" encoding="utf-8"?>
+<p:notes xmlns:a="http://schemas.openxmlformats.org/drawingml/2006/main" xmlns:r="http://schemas.openxmlformats.org/officeDocument/2006/relationships" xmlns:p="http://schemas.openxmlformats.org/presentationml/2006/main">
+  <p:cSld>
+    <p:spTree>
+      <p:nvGrpSpPr>
+        <p:cNvPr id="1" name=""/>
+        <p:cNvGrpSpPr/>
+        <p:nvPr/>
+      </p:nvGrpSpPr>
+      <p:grpSpPr>
+        <a:xfrm>
+          <a:off x="0" y="0"/>
+          <a:ext cx="0" cy="0"/>
+          <a:chOff x="0" y="0"/>
+          <a:chExt cx="0" cy="0"/>
+        </a:xfrm>
+      </p:grpSpPr>
+      <p:sp>
+        <p:nvSpPr>
+          <p:cNvPr id="2" name="Slide Image Placeholder 1"/>
+          <p:cNvSpPr>
+            <a:spLocks noGrp="1" noRot="1" noChangeAspect="1"/>
+          </p:cNvSpPr>
+          <p:nvPr>
+            <p:ph type="sldImg"/>
+          </p:nvPr>
+        </p:nvSpPr>
+        <p:spPr/>
+      </p:sp>
+      <p:sp>
+        <p:nvSpPr>
+          <p:cNvPr id="3" name="Notes Placeholder 2"/>
+          <p:cNvSpPr>
+            <a:spLocks noGrp="1"/>
+          </p:cNvSpPr>
+          <p:nvPr>
+            <p:ph type="body" idx="1"/>
+          </p:nvPr>
+        </p:nvSpPr>
+        <p:spPr/>
+        <p:txBody>
+          <a:bodyPr/>
+          <a:lstStyle/>
+          <a:p>
+            <a:r>
+              <a:rPr lang="en-US" dirty="0"/>
+              <a:t>Pattern: mockup. Style profile: technical. Window/card mockup for product, portal, or dashboard concepts.
+Slide 25: モックアップ: UIやポータルの概念を簡潔に示す
+mockup-visual: モックアップ (mockup) schematic sample
+mockup-visual long description: モックアップ (mockup) のサンプルです。Window/card mockup for product, portal, or dashboard concepts. pptcreater の安全なschematicプリセットで生成しています。</a:t>
+            </a:r>
+            <a:endParaRPr lang="en-US" dirty="0"/>
+          </a:p>
+        </p:txBody>
+      </p:sp>
+      <p:sp>
+        <p:nvSpPr>
+          <p:cNvPr id="4" name="Slide Number Placeholder 3"/>
+          <p:cNvSpPr>
+            <a:spLocks noGrp="1"/>
+          </p:cNvSpPr>
+          <p:nvPr>
+            <p:ph type="sldNum" sz="quarter" idx="10"/>
+          </p:nvPr>
+        </p:nvSpPr>
+        <p:spPr/>
+        <p:txBody>
+          <a:bodyPr/>
+          <a:lstStyle/>
+          <a:p>
+            <a:fld id="{F7021451-1387-4CA6-816F-3879F97B5CBC}" type="slidenum">
+              <a:rPr lang="en-US"/>
+              <a:t>25</a:t>
+            </a:fld>
+            <a:endParaRPr lang="en-US"/>
+          </a:p>
+        </p:txBody>
+      </p:sp>
+    </p:spTree>
+    <p:extLst>
+      <p:ext uri="{BB962C8B-B14F-4D97-AF65-F5344CB8AC3E}">
+        <p14:creationId xmlns:p14="http://schemas.microsoft.com/office/powerpoint/2010/main" val="1024086991"/>
+      </p:ext>
+    </p:extLst>
+  </p:cSld>
+  <p:clrMapOvr>
+    <a:masterClrMapping/>
+  </p:clrMapOvr>
+</p:notes>
+</file>
+
+<file path=ppt/notesSlides/notesSlide26.xml><?xml version="1.0" encoding="utf-8"?>
+<p:notes xmlns:a="http://schemas.openxmlformats.org/drawingml/2006/main" xmlns:r="http://schemas.openxmlformats.org/officeDocument/2006/relationships" xmlns:p="http://schemas.openxmlformats.org/presentationml/2006/main">
+  <p:cSld>
+    <p:spTree>
+      <p:nvGrpSpPr>
+        <p:cNvPr id="1" name=""/>
+        <p:cNvGrpSpPr/>
+        <p:nvPr/>
+      </p:nvGrpSpPr>
+      <p:grpSpPr>
+        <a:xfrm>
+          <a:off x="0" y="0"/>
+          <a:ext cx="0" cy="0"/>
+          <a:chOff x="0" y="0"/>
+          <a:chExt cx="0" cy="0"/>
+        </a:xfrm>
+      </p:grpSpPr>
+      <p:sp>
+        <p:nvSpPr>
+          <p:cNvPr id="2" name="Slide Image Placeholder 1"/>
+          <p:cNvSpPr>
+            <a:spLocks noGrp="1" noRot="1" noChangeAspect="1"/>
+          </p:cNvSpPr>
+          <p:nvPr>
+            <p:ph type="sldImg"/>
+          </p:nvPr>
+        </p:nvSpPr>
+        <p:spPr/>
+      </p:sp>
+      <p:sp>
+        <p:nvSpPr>
+          <p:cNvPr id="3" name="Notes Placeholder 2"/>
+          <p:cNvSpPr>
+            <a:spLocks noGrp="1"/>
+          </p:cNvSpPr>
+          <p:nvPr>
+            <p:ph type="body" idx="1"/>
+          </p:nvPr>
+        </p:nvSpPr>
+        <p:spPr/>
+        <p:txBody>
+          <a:bodyPr/>
+          <a:lstStyle/>
+          <a:p>
+            <a:r>
+              <a:rPr lang="en-US" dirty="0"/>
+              <a:t>Source URLs and attribution:
+1. Slideland schematic and taste references | URL: https://www.slideland.tech/docs/schematic | Notes: Layouts are inspired by common schematic categories, not copied from source visuals.
+Slide 26: 参考URL・出典</a:t>
+            </a:r>
+            <a:endParaRPr lang="en-US" dirty="0"/>
+          </a:p>
+        </p:txBody>
+      </p:sp>
+      <p:sp>
+        <p:nvSpPr>
+          <p:cNvPr id="4" name="Slide Number Placeholder 3"/>
+          <p:cNvSpPr>
+            <a:spLocks noGrp="1"/>
+          </p:cNvSpPr>
+          <p:nvPr>
+            <p:ph type="sldNum" sz="quarter" idx="10"/>
+          </p:nvPr>
+        </p:nvSpPr>
+        <p:spPr/>
+        <p:txBody>
+          <a:bodyPr/>
+          <a:lstStyle/>
+          <a:p>
+            <a:fld id="{F7021451-1387-4CA6-816F-3879F97B5CBC}" type="slidenum">
+              <a:rPr lang="en-US"/>
+              <a:t>26</a:t>
+            </a:fld>
+            <a:endParaRPr lang="en-US"/>
+          </a:p>
+        </p:txBody>
+      </p:sp>
+    </p:spTree>
+    <p:extLst>
+      <p:ext uri="{BB962C8B-B14F-4D97-AF65-F5344CB8AC3E}">
+        <p14:creationId xmlns:p14="http://schemas.microsoft.com/office/powerpoint/2010/main" val="1024086991"/>
+      </p:ext>
+    </p:extLst>
+  </p:cSld>
+  <p:clrMapOvr>
+    <a:masterClrMapping/>
+  </p:clrMapOvr>
+</p:notes>
+</file>
+
 <file path=ppt/notesSlides/notesSlide3.xml><?xml version="1.0" encoding="utf-8"?>
 <p:notes xmlns:a="http://schemas.openxmlformats.org/drawingml/2006/main" xmlns:r="http://schemas.openxmlformats.org/officeDocument/2006/relationships" xmlns:p="http://schemas.openxmlformats.org/presentationml/2006/main">
   <p:cSld>
@@ -688,10 +2255,10 @@
           <a:p>
             <a:r>
               <a:rPr lang="en-US" dirty="0"/>
-              <a:t>generate_schematic で生成した安全な図解プリセットの例です。
-Slide 3: ツリー: 複雑な情報を階層で整理する
-tree-visual: tree schematic sample
-tree-visual long description: tree schematic sample generated from a safe preset to demonstrate Slideland-inspired layouts in pptcreater.</a:t>
+              <a:t>Pattern: flow. Style profile: report. Left-to-right process, handoff, or customer journey.
+Slide 3: 横型フロー: 作成から検証までを迷わず進める
+flow-visual: 横フロー (flow) schematic sample
+flow-visual long description: 横フロー (flow) のサンプルです。Left-to-right process, handoff, or customer journey. pptcreater の安全なschematicプリセットで生成しています。</a:t>
             </a:r>
             <a:endParaRPr lang="en-US" dirty="0"/>
           </a:p>
@@ -779,10 +2346,10 @@
           <a:p>
             <a:r>
               <a:rPr lang="en-US" dirty="0"/>
-              <a:t>generate_schematic で生成した安全な図解プリセットの例です。
-Slide 4: 横並びリスト: 重要ポイントを短く見せる
-list-horizontal-visual: list-horizontal schematic sample
-list-horizontal-visual long description: list-horizontal schematic sample generated from a safe preset to demonstrate Slideland-inspired layouts in pptcreater.</a:t>
+              <a:t>Pattern: vertical-flow. Style profile: presentation. Top-to-bottom sequence for procedures or escalation paths.
+Slide 4: 縦型フロー: 承認プロセスを上から下へ示す
+vertical-flow-visual: 縦フロー (vertical-flow) schematic sample
+vertical-flow-visual long description: 縦フロー (vertical-flow) のサンプルです。Top-to-bottom sequence for procedures or escalation paths. pptcreater の安全なschematicプリセットで生成しています。</a:t>
             </a:r>
             <a:endParaRPr lang="en-US" dirty="0"/>
           </a:p>
@@ -870,9 +2437,10 @@
           <a:p>
             <a:r>
               <a:rPr lang="en-US" dirty="0"/>
-              <a:t>Source URLs and attribution:
-1. Slideland schematic and taste references | URL: https://www.slideland.tech/ | Notes: Layouts are inspired by common schematic categories, not copied from source visuals.
-Slide 5: 参考URL・出典</a:t>
+              <a:t>Pattern: cycle. Style profile: technical. Repeating loop with directional relationships.
+Slide 5: サイクル: 継続改善を循環で見せる
+cycle-visual: サイクル (cycle) schematic sample
+cycle-visual long description: サイクル (cycle) のサンプルです。Repeating loop with directional relationships. pptcreater の安全なschematicプリセットで生成しています。</a:t>
             </a:r>
             <a:endParaRPr lang="en-US" dirty="0"/>
           </a:p>
@@ -896,6 +2464,370 @@
             <a:fld id="{F7021451-1387-4CA6-816F-3879F97B5CBC}" type="slidenum">
               <a:rPr lang="en-US"/>
               <a:t>5</a:t>
+            </a:fld>
+            <a:endParaRPr lang="en-US"/>
+          </a:p>
+        </p:txBody>
+      </p:sp>
+    </p:spTree>
+    <p:extLst>
+      <p:ext uri="{BB962C8B-B14F-4D97-AF65-F5344CB8AC3E}">
+        <p14:creationId xmlns:p14="http://schemas.microsoft.com/office/powerpoint/2010/main" val="1024086991"/>
+      </p:ext>
+    </p:extLst>
+  </p:cSld>
+  <p:clrMapOvr>
+    <a:masterClrMapping/>
+  </p:clrMapOvr>
+</p:notes>
+</file>
+
+<file path=ppt/notesSlides/notesSlide6.xml><?xml version="1.0" encoding="utf-8"?>
+<p:notes xmlns:a="http://schemas.openxmlformats.org/drawingml/2006/main" xmlns:r="http://schemas.openxmlformats.org/officeDocument/2006/relationships" xmlns:p="http://schemas.openxmlformats.org/presentationml/2006/main">
+  <p:cSld>
+    <p:spTree>
+      <p:nvGrpSpPr>
+        <p:cNvPr id="1" name=""/>
+        <p:cNvGrpSpPr/>
+        <p:nvPr/>
+      </p:nvGrpSpPr>
+      <p:grpSpPr>
+        <a:xfrm>
+          <a:off x="0" y="0"/>
+          <a:ext cx="0" cy="0"/>
+          <a:chOff x="0" y="0"/>
+          <a:chExt cx="0" cy="0"/>
+        </a:xfrm>
+      </p:grpSpPr>
+      <p:sp>
+        <p:nvSpPr>
+          <p:cNvPr id="2" name="Slide Image Placeholder 1"/>
+          <p:cNvSpPr>
+            <a:spLocks noGrp="1" noRot="1" noChangeAspect="1"/>
+          </p:cNvSpPr>
+          <p:nvPr>
+            <p:ph type="sldImg"/>
+          </p:nvPr>
+        </p:nvSpPr>
+        <p:spPr/>
+      </p:sp>
+      <p:sp>
+        <p:nvSpPr>
+          <p:cNvPr id="3" name="Notes Placeholder 2"/>
+          <p:cNvSpPr>
+            <a:spLocks noGrp="1"/>
+          </p:cNvSpPr>
+          <p:nvPr>
+            <p:ph type="body" idx="1"/>
+          </p:nvPr>
+        </p:nvSpPr>
+        <p:spPr/>
+        <p:txBody>
+          <a:bodyPr/>
+          <a:lstStyle/>
+          <a:p>
+            <a:r>
+              <a:rPr lang="en-US" dirty="0"/>
+              <a:t>Pattern: before-after. Style profile: minimal. Current state versus target state with a central transition.
+Slide 6: 前後比較: 現状と改善後の差分を見せる
+before-after-visual: 前後比較 (before-after) schematic sample
+before-after-visual long description: 前後比較 (before-after) のサンプルです。Current state versus target state with a central transition. pptcreater の安全なschematicプリセットで生成しています。</a:t>
+            </a:r>
+            <a:endParaRPr lang="en-US" dirty="0"/>
+          </a:p>
+        </p:txBody>
+      </p:sp>
+      <p:sp>
+        <p:nvSpPr>
+          <p:cNvPr id="4" name="Slide Number Placeholder 3"/>
+          <p:cNvSpPr>
+            <a:spLocks noGrp="1"/>
+          </p:cNvSpPr>
+          <p:nvPr>
+            <p:ph type="sldNum" sz="quarter" idx="10"/>
+          </p:nvPr>
+        </p:nvSpPr>
+        <p:spPr/>
+        <p:txBody>
+          <a:bodyPr/>
+          <a:lstStyle/>
+          <a:p>
+            <a:fld id="{F7021451-1387-4CA6-816F-3879F97B5CBC}" type="slidenum">
+              <a:rPr lang="en-US"/>
+              <a:t>6</a:t>
+            </a:fld>
+            <a:endParaRPr lang="en-US"/>
+          </a:p>
+        </p:txBody>
+      </p:sp>
+    </p:spTree>
+    <p:extLst>
+      <p:ext uri="{BB962C8B-B14F-4D97-AF65-F5344CB8AC3E}">
+        <p14:creationId xmlns:p14="http://schemas.microsoft.com/office/powerpoint/2010/main" val="1024086991"/>
+      </p:ext>
+    </p:extLst>
+  </p:cSld>
+  <p:clrMapOvr>
+    <a:masterClrMapping/>
+  </p:clrMapOvr>
+</p:notes>
+</file>
+
+<file path=ppt/notesSlides/notesSlide7.xml><?xml version="1.0" encoding="utf-8"?>
+<p:notes xmlns:a="http://schemas.openxmlformats.org/drawingml/2006/main" xmlns:r="http://schemas.openxmlformats.org/officeDocument/2006/relationships" xmlns:p="http://schemas.openxmlformats.org/presentationml/2006/main">
+  <p:cSld>
+    <p:spTree>
+      <p:nvGrpSpPr>
+        <p:cNvPr id="1" name=""/>
+        <p:cNvGrpSpPr/>
+        <p:nvPr/>
+      </p:nvGrpSpPr>
+      <p:grpSpPr>
+        <a:xfrm>
+          <a:off x="0" y="0"/>
+          <a:ext cx="0" cy="0"/>
+          <a:chOff x="0" y="0"/>
+          <a:chExt cx="0" cy="0"/>
+        </a:xfrm>
+      </p:grpSpPr>
+      <p:sp>
+        <p:nvSpPr>
+          <p:cNvPr id="2" name="Slide Image Placeholder 1"/>
+          <p:cNvSpPr>
+            <a:spLocks noGrp="1" noRot="1" noChangeAspect="1"/>
+          </p:cNvSpPr>
+          <p:nvPr>
+            <p:ph type="sldImg"/>
+          </p:nvPr>
+        </p:nvSpPr>
+        <p:spPr/>
+      </p:sp>
+      <p:sp>
+        <p:nvSpPr>
+          <p:cNvPr id="3" name="Notes Placeholder 2"/>
+          <p:cNvSpPr>
+            <a:spLocks noGrp="1"/>
+          </p:cNvSpPr>
+          <p:nvPr>
+            <p:ph type="body" idx="1"/>
+          </p:nvPr>
+        </p:nvSpPr>
+        <p:spPr/>
+        <p:txBody>
+          <a:bodyPr/>
+          <a:lstStyle/>
+          <a:p>
+            <a:r>
+              <a:rPr lang="en-US" dirty="0"/>
+              <a:t>Pattern: map. Style profile: stylish. Spatial control map or conceptual territory with numbered locations.
+Slide 7: マップ: 制御ポイントを空間的に把握する
+map-visual: マップ (map) schematic sample
+map-visual long description: マップ (map) のサンプルです。Spatial control map or conceptual territory with numbered locations. pptcreater の安全なschematicプリセットで生成しています。</a:t>
+            </a:r>
+            <a:endParaRPr lang="en-US" dirty="0"/>
+          </a:p>
+        </p:txBody>
+      </p:sp>
+      <p:sp>
+        <p:nvSpPr>
+          <p:cNvPr id="4" name="Slide Number Placeholder 3"/>
+          <p:cNvSpPr>
+            <a:spLocks noGrp="1"/>
+          </p:cNvSpPr>
+          <p:nvPr>
+            <p:ph type="sldNum" sz="quarter" idx="10"/>
+          </p:nvPr>
+        </p:nvSpPr>
+        <p:spPr/>
+        <p:txBody>
+          <a:bodyPr/>
+          <a:lstStyle/>
+          <a:p>
+            <a:fld id="{F7021451-1387-4CA6-816F-3879F97B5CBC}" type="slidenum">
+              <a:rPr lang="en-US"/>
+              <a:t>7</a:t>
+            </a:fld>
+            <a:endParaRPr lang="en-US"/>
+          </a:p>
+        </p:txBody>
+      </p:sp>
+    </p:spTree>
+    <p:extLst>
+      <p:ext uri="{BB962C8B-B14F-4D97-AF65-F5344CB8AC3E}">
+        <p14:creationId xmlns:p14="http://schemas.microsoft.com/office/powerpoint/2010/main" val="1024086991"/>
+      </p:ext>
+    </p:extLst>
+  </p:cSld>
+  <p:clrMapOvr>
+    <a:masterClrMapping/>
+  </p:clrMapOvr>
+</p:notes>
+</file>
+
+<file path=ppt/notesSlides/notesSlide8.xml><?xml version="1.0" encoding="utf-8"?>
+<p:notes xmlns:a="http://schemas.openxmlformats.org/drawingml/2006/main" xmlns:r="http://schemas.openxmlformats.org/officeDocument/2006/relationships" xmlns:p="http://schemas.openxmlformats.org/presentationml/2006/main">
+  <p:cSld>
+    <p:spTree>
+      <p:nvGrpSpPr>
+        <p:cNvPr id="1" name=""/>
+        <p:cNvGrpSpPr/>
+        <p:nvPr/>
+      </p:nvGrpSpPr>
+      <p:grpSpPr>
+        <a:xfrm>
+          <a:off x="0" y="0"/>
+          <a:ext cx="0" cy="0"/>
+          <a:chOff x="0" y="0"/>
+          <a:chExt cx="0" cy="0"/>
+        </a:xfrm>
+      </p:grpSpPr>
+      <p:sp>
+        <p:nvSpPr>
+          <p:cNvPr id="2" name="Slide Image Placeholder 1"/>
+          <p:cNvSpPr>
+            <a:spLocks noGrp="1" noRot="1" noChangeAspect="1"/>
+          </p:cNvSpPr>
+          <p:nvPr>
+            <p:ph type="sldImg"/>
+          </p:nvPr>
+        </p:nvSpPr>
+        <p:spPr/>
+      </p:sp>
+      <p:sp>
+        <p:nvSpPr>
+          <p:cNvPr id="3" name="Notes Placeholder 2"/>
+          <p:cNvSpPr>
+            <a:spLocks noGrp="1"/>
+          </p:cNvSpPr>
+          <p:nvPr>
+            <p:ph type="body" idx="1"/>
+          </p:nvPr>
+        </p:nvSpPr>
+        <p:spPr/>
+        <p:txBody>
+          <a:bodyPr/>
+          <a:lstStyle/>
+          <a:p>
+            <a:r>
+              <a:rPr lang="en-US" dirty="0"/>
+              <a:t>Pattern: puzzle. Style profile: report. Interlocking modules that form one capability set.
+Slide 8: パズル/ハニカム: 構成要素を一体感で示す
+puzzle-visual: パズル/ハニカム (puzzle) schematic sample
+puzzle-visual long description: パズル/ハニカム (puzzle) のサンプルです。Interlocking modules that form one capability set. pptcreater の安全なschematicプリセットで生成しています。</a:t>
+            </a:r>
+            <a:endParaRPr lang="en-US" dirty="0"/>
+          </a:p>
+        </p:txBody>
+      </p:sp>
+      <p:sp>
+        <p:nvSpPr>
+          <p:cNvPr id="4" name="Slide Number Placeholder 3"/>
+          <p:cNvSpPr>
+            <a:spLocks noGrp="1"/>
+          </p:cNvSpPr>
+          <p:nvPr>
+            <p:ph type="sldNum" sz="quarter" idx="10"/>
+          </p:nvPr>
+        </p:nvSpPr>
+        <p:spPr/>
+        <p:txBody>
+          <a:bodyPr/>
+          <a:lstStyle/>
+          <a:p>
+            <a:fld id="{F7021451-1387-4CA6-816F-3879F97B5CBC}" type="slidenum">
+              <a:rPr lang="en-US"/>
+              <a:t>8</a:t>
+            </a:fld>
+            <a:endParaRPr lang="en-US"/>
+          </a:p>
+        </p:txBody>
+      </p:sp>
+    </p:spTree>
+    <p:extLst>
+      <p:ext uri="{BB962C8B-B14F-4D97-AF65-F5344CB8AC3E}">
+        <p14:creationId xmlns:p14="http://schemas.microsoft.com/office/powerpoint/2010/main" val="1024086991"/>
+      </p:ext>
+    </p:extLst>
+  </p:cSld>
+  <p:clrMapOvr>
+    <a:masterClrMapping/>
+  </p:clrMapOvr>
+</p:notes>
+</file>
+
+<file path=ppt/notesSlides/notesSlide9.xml><?xml version="1.0" encoding="utf-8"?>
+<p:notes xmlns:a="http://schemas.openxmlformats.org/drawingml/2006/main" xmlns:r="http://schemas.openxmlformats.org/officeDocument/2006/relationships" xmlns:p="http://schemas.openxmlformats.org/presentationml/2006/main">
+  <p:cSld>
+    <p:spTree>
+      <p:nvGrpSpPr>
+        <p:cNvPr id="1" name=""/>
+        <p:cNvGrpSpPr/>
+        <p:nvPr/>
+      </p:nvGrpSpPr>
+      <p:grpSpPr>
+        <a:xfrm>
+          <a:off x="0" y="0"/>
+          <a:ext cx="0" cy="0"/>
+          <a:chOff x="0" y="0"/>
+          <a:chExt cx="0" cy="0"/>
+        </a:xfrm>
+      </p:grpSpPr>
+      <p:sp>
+        <p:nvSpPr>
+          <p:cNvPr id="2" name="Slide Image Placeholder 1"/>
+          <p:cNvSpPr>
+            <a:spLocks noGrp="1" noRot="1" noChangeAspect="1"/>
+          </p:cNvSpPr>
+          <p:nvPr>
+            <p:ph type="sldImg"/>
+          </p:nvPr>
+        </p:nvSpPr>
+        <p:spPr/>
+      </p:sp>
+      <p:sp>
+        <p:nvSpPr>
+          <p:cNvPr id="3" name="Notes Placeholder 2"/>
+          <p:cNvSpPr>
+            <a:spLocks noGrp="1"/>
+          </p:cNvSpPr>
+          <p:nvPr>
+            <p:ph type="body" idx="1"/>
+          </p:nvPr>
+        </p:nvSpPr>
+        <p:spPr/>
+        <p:txBody>
+          <a:bodyPr/>
+          <a:lstStyle/>
+          <a:p>
+            <a:r>
+              <a:rPr lang="en-US" dirty="0"/>
+              <a:t>Pattern: correlation. Style profile: presentation. Central concept with related surrounding ideas and optional relationship labels.
+Slide 9: 相関図: 中心概念と周辺要素の関係を示す
+correlation-visual: 相関図/概念図 (correlation) schematic sample
+correlation-visual long description: 相関図/概念図 (correlation) のサンプルです。Central concept with related surrounding ideas and optional relationship labels. pptcreater の安全なschematicプリセットで生成しています。</a:t>
+            </a:r>
+            <a:endParaRPr lang="en-US" dirty="0"/>
+          </a:p>
+        </p:txBody>
+      </p:sp>
+      <p:sp>
+        <p:nvSpPr>
+          <p:cNvPr id="4" name="Slide Number Placeholder 3"/>
+          <p:cNvSpPr>
+            <a:spLocks noGrp="1"/>
+          </p:cNvSpPr>
+          <p:nvPr>
+            <p:ph type="sldNum" sz="quarter" idx="10"/>
+          </p:nvPr>
+        </p:nvSpPr>
+        <p:spPr/>
+        <p:txBody>
+          <a:bodyPr/>
+          <a:lstStyle/>
+          <a:p>
+            <a:fld id="{F7021451-1387-4CA6-816F-3879F97B5CBC}" type="slidenum">
+              <a:rPr lang="en-US"/>
+              <a:t>9</a:t>
             </a:fld>
             <a:endParaRPr lang="en-US"/>
           </a:p>
@@ -1247,7 +3179,7 @@
       </p:grpSpPr>
       <p:pic>
         <p:nvPicPr>
-          <p:cNvPr id="2" name="Image 0" descr="flow schematic sample">    </p:cNvPr>
+          <p:cNvPr id="2" name="Image 0" descr="表 (table) schematic sample">    </p:cNvPr>
           <p:cNvPicPr>
             <a:picLocks noChangeAspect="1"/>
           </p:cNvPicPr>
@@ -1267,8 +3199,8 @@
         </p:blipFill>
         <p:spPr>
           <a:xfrm>
-            <a:off x="530352" y="530352"/>
-            <a:ext cx="11128248" cy="5797296"/>
+            <a:off x="0" y="0"/>
+            <a:ext cx="12191695" cy="6858000"/>
           </a:xfrm>
           <a:prstGeom prst="rect">
             <a:avLst/>
@@ -1283,9 +3215,9 @@
 </p:sld>
 </file>
 
-<file path=ppt/slides/slide2.xml><?xml version="1.0" encoding="utf-8"?>
+<file path=ppt/slides/slide10.xml><?xml version="1.0" encoding="utf-8"?>
 <p:sld xmlns:a="http://schemas.openxmlformats.org/drawingml/2006/main" xmlns:r="http://schemas.openxmlformats.org/officeDocument/2006/relationships" xmlns:p="http://schemas.openxmlformats.org/presentationml/2006/main">
-  <p:cSld name="Slide 2">
+  <p:cSld name="Slide 10">
     <p:bg>
       <p:bgPr>
         <a:solidFill>
@@ -1309,7 +3241,7 @@
       </p:grpSpPr>
       <p:pic>
         <p:nvPicPr>
-          <p:cNvPr id="2" name="Image 0" descr="table schematic sample">    </p:cNvPr>
+          <p:cNvPr id="2" name="Image 0" descr="マトリクス (matrix) schematic sample">    </p:cNvPr>
           <p:cNvPicPr>
             <a:picLocks noChangeAspect="1"/>
           </p:cNvPicPr>
@@ -1329,8 +3261,8 @@
         </p:blipFill>
         <p:spPr>
           <a:xfrm>
-            <a:off x="530352" y="530352"/>
-            <a:ext cx="11128248" cy="5797296"/>
+            <a:off x="0" y="0"/>
+            <a:ext cx="12191695" cy="6858000"/>
           </a:xfrm>
           <a:prstGeom prst="rect">
             <a:avLst/>
@@ -1345,9 +3277,9 @@
 </p:sld>
 </file>
 
-<file path=ppt/slides/slide3.xml><?xml version="1.0" encoding="utf-8"?>
+<file path=ppt/slides/slide11.xml><?xml version="1.0" encoding="utf-8"?>
 <p:sld xmlns:a="http://schemas.openxmlformats.org/drawingml/2006/main" xmlns:r="http://schemas.openxmlformats.org/officeDocument/2006/relationships" xmlns:p="http://schemas.openxmlformats.org/presentationml/2006/main">
-  <p:cSld name="Slide 3">
+  <p:cSld name="Slide 11">
     <p:bg>
       <p:bgPr>
         <a:solidFill>
@@ -1371,7 +3303,7 @@
       </p:grpSpPr>
       <p:pic>
         <p:nvPicPr>
-          <p:cNvPr id="2" name="Image 0" descr="tree schematic sample">    </p:cNvPr>
+          <p:cNvPr id="2" name="Image 0" descr="ベン図 (venn) schematic sample">    </p:cNvPr>
           <p:cNvPicPr>
             <a:picLocks noChangeAspect="1"/>
           </p:cNvPicPr>
@@ -1391,8 +3323,8 @@
         </p:blipFill>
         <p:spPr>
           <a:xfrm>
-            <a:off x="530352" y="530352"/>
-            <a:ext cx="11128248" cy="5797296"/>
+            <a:off x="0" y="0"/>
+            <a:ext cx="12191695" cy="6858000"/>
           </a:xfrm>
           <a:prstGeom prst="rect">
             <a:avLst/>
@@ -1407,9 +3339,9 @@
 </p:sld>
 </file>
 
-<file path=ppt/slides/slide4.xml><?xml version="1.0" encoding="utf-8"?>
+<file path=ppt/slides/slide12.xml><?xml version="1.0" encoding="utf-8"?>
 <p:sld xmlns:a="http://schemas.openxmlformats.org/drawingml/2006/main" xmlns:r="http://schemas.openxmlformats.org/officeDocument/2006/relationships" xmlns:p="http://schemas.openxmlformats.org/presentationml/2006/main">
-  <p:cSld name="Slide 4">
+  <p:cSld name="Slide 12">
     <p:bg>
       <p:bgPr>
         <a:solidFill>
@@ -1433,7 +3365,7 @@
       </p:grpSpPr>
       <p:pic>
         <p:nvPicPr>
-          <p:cNvPr id="2" name="Image 0" descr="list-horizontal schematic sample">    </p:cNvPr>
+          <p:cNvPr id="2" name="Image 0" descr="数式 (cross) schematic sample">    </p:cNvPr>
           <p:cNvPicPr>
             <a:picLocks noChangeAspect="1"/>
           </p:cNvPicPr>
@@ -1453,8 +3385,8 @@
         </p:blipFill>
         <p:spPr>
           <a:xfrm>
-            <a:off x="530352" y="530352"/>
-            <a:ext cx="11128248" cy="5797296"/>
+            <a:off x="0" y="0"/>
+            <a:ext cx="12191695" cy="6858000"/>
           </a:xfrm>
           <a:prstGeom prst="rect">
             <a:avLst/>
@@ -1469,9 +3401,877 @@
 </p:sld>
 </file>
 
-<file path=ppt/slides/slide5.xml><?xml version="1.0" encoding="utf-8"?>
+<file path=ppt/slides/slide13.xml><?xml version="1.0" encoding="utf-8"?>
 <p:sld xmlns:a="http://schemas.openxmlformats.org/drawingml/2006/main" xmlns:r="http://schemas.openxmlformats.org/officeDocument/2006/relationships" xmlns:p="http://schemas.openxmlformats.org/presentationml/2006/main">
-  <p:cSld name="Slide 5">
+  <p:cSld name="Slide 13">
+    <p:bg>
+      <p:bgPr>
+        <a:solidFill>
+          <a:srgbClr val="FFFFFF"/>
+        </a:solidFill>
+      </p:bgPr>
+    </p:bg>
+    <p:spTree>
+      <p:nvGrpSpPr>
+        <p:cNvPr id="1" name=""/>
+        <p:cNvGrpSpPr/>
+        <p:nvPr/>
+      </p:nvGrpSpPr>
+      <p:grpSpPr>
+        <a:xfrm>
+          <a:off x="0" y="0"/>
+          <a:ext cx="0" cy="0"/>
+          <a:chOff x="0" y="0"/>
+          <a:chExt cx="0" cy="0"/>
+        </a:xfrm>
+      </p:grpSpPr>
+      <p:pic>
+        <p:nvPicPr>
+          <p:cNvPr id="2" name="Image 0" descr="グループ/集合 (set) schematic sample">    </p:cNvPr>
+          <p:cNvPicPr>
+            <a:picLocks noChangeAspect="1"/>
+          </p:cNvPicPr>
+          <p:nvPr/>
+        </p:nvPicPr>
+        <p:blipFill>
+          <a:blip r:embed="rId1">
+            <a:extLst>
+              <a:ext uri="{96DAC541-7B7A-43D3-8B79-37D633B846F1}">
+                <asvg:svgBlip xmlns:asvg="http://schemas.microsoft.com/office/drawing/2016/SVG/main" r:embed="rId2"/>
+              </a:ext>
+            </a:extLst>
+          </a:blip>
+          <a:stretch>
+            <a:fillRect/>
+          </a:stretch>
+        </p:blipFill>
+        <p:spPr>
+          <a:xfrm>
+            <a:off x="0" y="0"/>
+            <a:ext cx="12191695" cy="6858000"/>
+          </a:xfrm>
+          <a:prstGeom prst="rect">
+            <a:avLst/>
+          </a:prstGeom>
+        </p:spPr>
+      </p:pic>
+    </p:spTree>
+  </p:cSld>
+  <p:clrMapOvr>
+    <a:masterClrMapping/>
+  </p:clrMapOvr>
+</p:sld>
+</file>
+
+<file path=ppt/slides/slide14.xml><?xml version="1.0" encoding="utf-8"?>
+<p:sld xmlns:a="http://schemas.openxmlformats.org/drawingml/2006/main" xmlns:r="http://schemas.openxmlformats.org/officeDocument/2006/relationships" xmlns:p="http://schemas.openxmlformats.org/presentationml/2006/main">
+  <p:cSld name="Slide 14">
+    <p:bg>
+      <p:bgPr>
+        <a:solidFill>
+          <a:srgbClr val="FFFFFF"/>
+        </a:solidFill>
+      </p:bgPr>
+    </p:bg>
+    <p:spTree>
+      <p:nvGrpSpPr>
+        <p:cNvPr id="1" name=""/>
+        <p:cNvGrpSpPr/>
+        <p:nvPr/>
+      </p:nvGrpSpPr>
+      <p:grpSpPr>
+        <a:xfrm>
+          <a:off x="0" y="0"/>
+          <a:ext cx="0" cy="0"/>
+          <a:chOff x="0" y="0"/>
+          <a:chExt cx="0" cy="0"/>
+        </a:xfrm>
+      </p:grpSpPr>
+      <p:pic>
+        <p:nvPicPr>
+          <p:cNvPr id="2" name="Image 0" descr="項目比較 (contrast) schematic sample">    </p:cNvPr>
+          <p:cNvPicPr>
+            <a:picLocks noChangeAspect="1"/>
+          </p:cNvPicPr>
+          <p:nvPr/>
+        </p:nvPicPr>
+        <p:blipFill>
+          <a:blip r:embed="rId1">
+            <a:extLst>
+              <a:ext uri="{96DAC541-7B7A-43D3-8B79-37D633B846F1}">
+                <asvg:svgBlip xmlns:asvg="http://schemas.microsoft.com/office/drawing/2016/SVG/main" r:embed="rId2"/>
+              </a:ext>
+            </a:extLst>
+          </a:blip>
+          <a:stretch>
+            <a:fillRect/>
+          </a:stretch>
+        </p:blipFill>
+        <p:spPr>
+          <a:xfrm>
+            <a:off x="0" y="0"/>
+            <a:ext cx="12191695" cy="6858000"/>
+          </a:xfrm>
+          <a:prstGeom prst="rect">
+            <a:avLst/>
+          </a:prstGeom>
+        </p:spPr>
+      </p:pic>
+    </p:spTree>
+  </p:cSld>
+  <p:clrMapOvr>
+    <a:masterClrMapping/>
+  </p:clrMapOvr>
+</p:sld>
+</file>
+
+<file path=ppt/slides/slide15.xml><?xml version="1.0" encoding="utf-8"?>
+<p:sld xmlns:a="http://schemas.openxmlformats.org/drawingml/2006/main" xmlns:r="http://schemas.openxmlformats.org/officeDocument/2006/relationships" xmlns:p="http://schemas.openxmlformats.org/presentationml/2006/main">
+  <p:cSld name="Slide 15">
+    <p:bg>
+      <p:bgPr>
+        <a:solidFill>
+          <a:srgbClr val="FFFFFF"/>
+        </a:solidFill>
+      </p:bgPr>
+    </p:bg>
+    <p:spTree>
+      <p:nvGrpSpPr>
+        <p:cNvPr id="1" name=""/>
+        <p:cNvGrpSpPr/>
+        <p:nvPr/>
+      </p:nvGrpSpPr>
+      <p:grpSpPr>
+        <a:xfrm>
+          <a:off x="0" y="0"/>
+          <a:ext cx="0" cy="0"/>
+          <a:chOff x="0" y="0"/>
+          <a:chExt cx="0" cy="0"/>
+        </a:xfrm>
+      </p:grpSpPr>
+      <p:pic>
+        <p:nvPicPr>
+          <p:cNvPr id="2" name="Image 0" descr="規模比較 (scale-contrast) schematic sample">    </p:cNvPr>
+          <p:cNvPicPr>
+            <a:picLocks noChangeAspect="1"/>
+          </p:cNvPicPr>
+          <p:nvPr/>
+        </p:nvPicPr>
+        <p:blipFill>
+          <a:blip r:embed="rId1">
+            <a:extLst>
+              <a:ext uri="{96DAC541-7B7A-43D3-8B79-37D633B846F1}">
+                <asvg:svgBlip xmlns:asvg="http://schemas.microsoft.com/office/drawing/2016/SVG/main" r:embed="rId2"/>
+              </a:ext>
+            </a:extLst>
+          </a:blip>
+          <a:stretch>
+            <a:fillRect/>
+          </a:stretch>
+        </p:blipFill>
+        <p:spPr>
+          <a:xfrm>
+            <a:off x="0" y="0"/>
+            <a:ext cx="12191695" cy="6858000"/>
+          </a:xfrm>
+          <a:prstGeom prst="rect">
+            <a:avLst/>
+          </a:prstGeom>
+        </p:spPr>
+      </p:pic>
+    </p:spTree>
+  </p:cSld>
+  <p:clrMapOvr>
+    <a:masterClrMapping/>
+  </p:clrMapOvr>
+</p:sld>
+</file>
+
+<file path=ppt/slides/slide16.xml><?xml version="1.0" encoding="utf-8"?>
+<p:sld xmlns:a="http://schemas.openxmlformats.org/drawingml/2006/main" xmlns:r="http://schemas.openxmlformats.org/officeDocument/2006/relationships" xmlns:p="http://schemas.openxmlformats.org/presentationml/2006/main">
+  <p:cSld name="Slide 16">
+    <p:bg>
+      <p:bgPr>
+        <a:solidFill>
+          <a:srgbClr val="FFFFFF"/>
+        </a:solidFill>
+      </p:bgPr>
+    </p:bg>
+    <p:spTree>
+      <p:nvGrpSpPr>
+        <p:cNvPr id="1" name=""/>
+        <p:cNvGrpSpPr/>
+        <p:nvPr/>
+      </p:nvGrpSpPr>
+      <p:grpSpPr>
+        <a:xfrm>
+          <a:off x="0" y="0"/>
+          <a:ext cx="0" cy="0"/>
+          <a:chOff x="0" y="0"/>
+          <a:chExt cx="0" cy="0"/>
+        </a:xfrm>
+      </p:grpSpPr>
+      <p:pic>
+        <p:nvPicPr>
+          <p:cNvPr id="2" name="Image 0" descr="規模分析 (grow) schematic sample">    </p:cNvPr>
+          <p:cNvPicPr>
+            <a:picLocks noChangeAspect="1"/>
+          </p:cNvPicPr>
+          <p:nvPr/>
+        </p:nvPicPr>
+        <p:blipFill>
+          <a:blip r:embed="rId1">
+            <a:extLst>
+              <a:ext uri="{96DAC541-7B7A-43D3-8B79-37D633B846F1}">
+                <asvg:svgBlip xmlns:asvg="http://schemas.microsoft.com/office/drawing/2016/SVG/main" r:embed="rId2"/>
+              </a:ext>
+            </a:extLst>
+          </a:blip>
+          <a:stretch>
+            <a:fillRect/>
+          </a:stretch>
+        </p:blipFill>
+        <p:spPr>
+          <a:xfrm>
+            <a:off x="0" y="0"/>
+            <a:ext cx="12191695" cy="6858000"/>
+          </a:xfrm>
+          <a:prstGeom prst="rect">
+            <a:avLst/>
+          </a:prstGeom>
+        </p:spPr>
+      </p:pic>
+    </p:spTree>
+  </p:cSld>
+  <p:clrMapOvr>
+    <a:masterClrMapping/>
+  </p:clrMapOvr>
+</p:sld>
+</file>
+
+<file path=ppt/slides/slide17.xml><?xml version="1.0" encoding="utf-8"?>
+<p:sld xmlns:a="http://schemas.openxmlformats.org/drawingml/2006/main" xmlns:r="http://schemas.openxmlformats.org/officeDocument/2006/relationships" xmlns:p="http://schemas.openxmlformats.org/presentationml/2006/main">
+  <p:cSld name="Slide 17">
+    <p:bg>
+      <p:bgPr>
+        <a:solidFill>
+          <a:srgbClr val="FFFFFF"/>
+        </a:solidFill>
+      </p:bgPr>
+    </p:bg>
+    <p:spTree>
+      <p:nvGrpSpPr>
+        <p:cNvPr id="1" name=""/>
+        <p:cNvGrpSpPr/>
+        <p:nvPr/>
+      </p:nvGrpSpPr>
+      <p:grpSpPr>
+        <a:xfrm>
+          <a:off x="0" y="0"/>
+          <a:ext cx="0" cy="0"/>
+          <a:chOff x="0" y="0"/>
+          <a:chExt cx="0" cy="0"/>
+        </a:xfrm>
+      </p:grpSpPr>
+      <p:pic>
+        <p:nvPicPr>
+          <p:cNvPr id="2" name="Image 0" descr="レイヤー構造 (layer) schematic sample">    </p:cNvPr>
+          <p:cNvPicPr>
+            <a:picLocks noChangeAspect="1"/>
+          </p:cNvPicPr>
+          <p:nvPr/>
+        </p:nvPicPr>
+        <p:blipFill>
+          <a:blip r:embed="rId1">
+            <a:extLst>
+              <a:ext uri="{96DAC541-7B7A-43D3-8B79-37D633B846F1}">
+                <asvg:svgBlip xmlns:asvg="http://schemas.microsoft.com/office/drawing/2016/SVG/main" r:embed="rId2"/>
+              </a:ext>
+            </a:extLst>
+          </a:blip>
+          <a:stretch>
+            <a:fillRect/>
+          </a:stretch>
+        </p:blipFill>
+        <p:spPr>
+          <a:xfrm>
+            <a:off x="0" y="0"/>
+            <a:ext cx="12191695" cy="6858000"/>
+          </a:xfrm>
+          <a:prstGeom prst="rect">
+            <a:avLst/>
+          </a:prstGeom>
+        </p:spPr>
+      </p:pic>
+    </p:spTree>
+  </p:cSld>
+  <p:clrMapOvr>
+    <a:masterClrMapping/>
+  </p:clrMapOvr>
+</p:sld>
+</file>
+
+<file path=ppt/slides/slide18.xml><?xml version="1.0" encoding="utf-8"?>
+<p:sld xmlns:a="http://schemas.openxmlformats.org/drawingml/2006/main" xmlns:r="http://schemas.openxmlformats.org/officeDocument/2006/relationships" xmlns:p="http://schemas.openxmlformats.org/presentationml/2006/main">
+  <p:cSld name="Slide 18">
+    <p:bg>
+      <p:bgPr>
+        <a:solidFill>
+          <a:srgbClr val="FFFFFF"/>
+        </a:solidFill>
+      </p:bgPr>
+    </p:bg>
+    <p:spTree>
+      <p:nvGrpSpPr>
+        <p:cNvPr id="1" name=""/>
+        <p:cNvGrpSpPr/>
+        <p:nvPr/>
+      </p:nvGrpSpPr>
+      <p:grpSpPr>
+        <a:xfrm>
+          <a:off x="0" y="0"/>
+          <a:ext cx="0" cy="0"/>
+          <a:chOff x="0" y="0"/>
+          <a:chExt cx="0" cy="0"/>
+        </a:xfrm>
+      </p:grpSpPr>
+      <p:pic>
+        <p:nvPicPr>
+          <p:cNvPr id="2" name="Image 0" descr="トライアングル (triangle) schematic sample">    </p:cNvPr>
+          <p:cNvPicPr>
+            <a:picLocks noChangeAspect="1"/>
+          </p:cNvPicPr>
+          <p:nvPr/>
+        </p:nvPicPr>
+        <p:blipFill>
+          <a:blip r:embed="rId1">
+            <a:extLst>
+              <a:ext uri="{96DAC541-7B7A-43D3-8B79-37D633B846F1}">
+                <asvg:svgBlip xmlns:asvg="http://schemas.microsoft.com/office/drawing/2016/SVG/main" r:embed="rId2"/>
+              </a:ext>
+            </a:extLst>
+          </a:blip>
+          <a:stretch>
+            <a:fillRect/>
+          </a:stretch>
+        </p:blipFill>
+        <p:spPr>
+          <a:xfrm>
+            <a:off x="0" y="0"/>
+            <a:ext cx="12191695" cy="6858000"/>
+          </a:xfrm>
+          <a:prstGeom prst="rect">
+            <a:avLst/>
+          </a:prstGeom>
+        </p:spPr>
+      </p:pic>
+    </p:spTree>
+  </p:cSld>
+  <p:clrMapOvr>
+    <a:masterClrMapping/>
+  </p:clrMapOvr>
+</p:sld>
+</file>
+
+<file path=ppt/slides/slide19.xml><?xml version="1.0" encoding="utf-8"?>
+<p:sld xmlns:a="http://schemas.openxmlformats.org/drawingml/2006/main" xmlns:r="http://schemas.openxmlformats.org/officeDocument/2006/relationships" xmlns:p="http://schemas.openxmlformats.org/presentationml/2006/main">
+  <p:cSld name="Slide 19">
+    <p:bg>
+      <p:bgPr>
+        <a:solidFill>
+          <a:srgbClr val="FFFFFF"/>
+        </a:solidFill>
+      </p:bgPr>
+    </p:bg>
+    <p:spTree>
+      <p:nvGrpSpPr>
+        <p:cNvPr id="1" name=""/>
+        <p:cNvGrpSpPr/>
+        <p:nvPr/>
+      </p:nvGrpSpPr>
+      <p:grpSpPr>
+        <a:xfrm>
+          <a:off x="0" y="0"/>
+          <a:ext cx="0" cy="0"/>
+          <a:chOff x="0" y="0"/>
+          <a:chExt cx="0" cy="0"/>
+        </a:xfrm>
+      </p:grpSpPr>
+      <p:pic>
+        <p:nvPicPr>
+          <p:cNvPr id="2" name="Image 0" descr="階段/ステップ (step) schematic sample">    </p:cNvPr>
+          <p:cNvPicPr>
+            <a:picLocks noChangeAspect="1"/>
+          </p:cNvPicPr>
+          <p:nvPr/>
+        </p:nvPicPr>
+        <p:blipFill>
+          <a:blip r:embed="rId1">
+            <a:extLst>
+              <a:ext uri="{96DAC541-7B7A-43D3-8B79-37D633B846F1}">
+                <asvg:svgBlip xmlns:asvg="http://schemas.microsoft.com/office/drawing/2016/SVG/main" r:embed="rId2"/>
+              </a:ext>
+            </a:extLst>
+          </a:blip>
+          <a:stretch>
+            <a:fillRect/>
+          </a:stretch>
+        </p:blipFill>
+        <p:spPr>
+          <a:xfrm>
+            <a:off x="0" y="0"/>
+            <a:ext cx="12191695" cy="6858000"/>
+          </a:xfrm>
+          <a:prstGeom prst="rect">
+            <a:avLst/>
+          </a:prstGeom>
+        </p:spPr>
+      </p:pic>
+    </p:spTree>
+  </p:cSld>
+  <p:clrMapOvr>
+    <a:masterClrMapping/>
+  </p:clrMapOvr>
+</p:sld>
+</file>
+
+<file path=ppt/slides/slide2.xml><?xml version="1.0" encoding="utf-8"?>
+<p:sld xmlns:a="http://schemas.openxmlformats.org/drawingml/2006/main" xmlns:r="http://schemas.openxmlformats.org/officeDocument/2006/relationships" xmlns:p="http://schemas.openxmlformats.org/presentationml/2006/main">
+  <p:cSld name="Slide 2">
+    <p:bg>
+      <p:bgPr>
+        <a:solidFill>
+          <a:srgbClr val="FFFFFF"/>
+        </a:solidFill>
+      </p:bgPr>
+    </p:bg>
+    <p:spTree>
+      <p:nvGrpSpPr>
+        <p:cNvPr id="1" name=""/>
+        <p:cNvGrpSpPr/>
+        <p:nvPr/>
+      </p:nvGrpSpPr>
+      <p:grpSpPr>
+        <a:xfrm>
+          <a:off x="0" y="0"/>
+          <a:ext cx="0" cy="0"/>
+          <a:chOff x="0" y="0"/>
+          <a:chExt cx="0" cy="0"/>
+        </a:xfrm>
+      </p:grpSpPr>
+      <p:pic>
+        <p:nvPicPr>
+          <p:cNvPr id="2" name="Image 0" descr="ツリー (tree) schematic sample">    </p:cNvPr>
+          <p:cNvPicPr>
+            <a:picLocks noChangeAspect="1"/>
+          </p:cNvPicPr>
+          <p:nvPr/>
+        </p:nvPicPr>
+        <p:blipFill>
+          <a:blip r:embed="rId1">
+            <a:extLst>
+              <a:ext uri="{96DAC541-7B7A-43D3-8B79-37D633B846F1}">
+                <asvg:svgBlip xmlns:asvg="http://schemas.microsoft.com/office/drawing/2016/SVG/main" r:embed="rId2"/>
+              </a:ext>
+            </a:extLst>
+          </a:blip>
+          <a:stretch>
+            <a:fillRect/>
+          </a:stretch>
+        </p:blipFill>
+        <p:spPr>
+          <a:xfrm>
+            <a:off x="0" y="0"/>
+            <a:ext cx="12191695" cy="6858000"/>
+          </a:xfrm>
+          <a:prstGeom prst="rect">
+            <a:avLst/>
+          </a:prstGeom>
+        </p:spPr>
+      </p:pic>
+    </p:spTree>
+  </p:cSld>
+  <p:clrMapOvr>
+    <a:masterClrMapping/>
+  </p:clrMapOvr>
+</p:sld>
+</file>
+
+<file path=ppt/slides/slide20.xml><?xml version="1.0" encoding="utf-8"?>
+<p:sld xmlns:a="http://schemas.openxmlformats.org/drawingml/2006/main" xmlns:r="http://schemas.openxmlformats.org/officeDocument/2006/relationships" xmlns:p="http://schemas.openxmlformats.org/presentationml/2006/main">
+  <p:cSld name="Slide 20">
+    <p:bg>
+      <p:bgPr>
+        <a:solidFill>
+          <a:srgbClr val="FFFFFF"/>
+        </a:solidFill>
+      </p:bgPr>
+    </p:bg>
+    <p:spTree>
+      <p:nvGrpSpPr>
+        <p:cNvPr id="1" name=""/>
+        <p:cNvGrpSpPr/>
+        <p:nvPr/>
+      </p:nvGrpSpPr>
+      <p:grpSpPr>
+        <a:xfrm>
+          <a:off x="0" y="0"/>
+          <a:ext cx="0" cy="0"/>
+          <a:chOff x="0" y="0"/>
+          <a:chExt cx="0" cy="0"/>
+        </a:xfrm>
+      </p:grpSpPr>
+      <p:pic>
+        <p:nvPicPr>
+          <p:cNvPr id="2" name="Image 0" descr="ガントチャート (gantt) schematic sample">    </p:cNvPr>
+          <p:cNvPicPr>
+            <a:picLocks noChangeAspect="1"/>
+          </p:cNvPicPr>
+          <p:nvPr/>
+        </p:nvPicPr>
+        <p:blipFill>
+          <a:blip r:embed="rId1">
+            <a:extLst>
+              <a:ext uri="{96DAC541-7B7A-43D3-8B79-37D633B846F1}">
+                <asvg:svgBlip xmlns:asvg="http://schemas.microsoft.com/office/drawing/2016/SVG/main" r:embed="rId2"/>
+              </a:ext>
+            </a:extLst>
+          </a:blip>
+          <a:stretch>
+            <a:fillRect/>
+          </a:stretch>
+        </p:blipFill>
+        <p:spPr>
+          <a:xfrm>
+            <a:off x="0" y="0"/>
+            <a:ext cx="12191695" cy="6858000"/>
+          </a:xfrm>
+          <a:prstGeom prst="rect">
+            <a:avLst/>
+          </a:prstGeom>
+        </p:spPr>
+      </p:pic>
+    </p:spTree>
+  </p:cSld>
+  <p:clrMapOvr>
+    <a:masterClrMapping/>
+  </p:clrMapOvr>
+</p:sld>
+</file>
+
+<file path=ppt/slides/slide21.xml><?xml version="1.0" encoding="utf-8"?>
+<p:sld xmlns:a="http://schemas.openxmlformats.org/drawingml/2006/main" xmlns:r="http://schemas.openxmlformats.org/officeDocument/2006/relationships" xmlns:p="http://schemas.openxmlformats.org/presentationml/2006/main">
+  <p:cSld name="Slide 21">
+    <p:bg>
+      <p:bgPr>
+        <a:solidFill>
+          <a:srgbClr val="FFFFFF"/>
+        </a:solidFill>
+      </p:bgPr>
+    </p:bg>
+    <p:spTree>
+      <p:nvGrpSpPr>
+        <p:cNvPr id="1" name=""/>
+        <p:cNvGrpSpPr/>
+        <p:nvPr/>
+      </p:nvGrpSpPr>
+      <p:grpSpPr>
+        <a:xfrm>
+          <a:off x="0" y="0"/>
+          <a:ext cx="0" cy="0"/>
+          <a:chOff x="0" y="0"/>
+          <a:chExt cx="0" cy="0"/>
+        </a:xfrm>
+      </p:grpSpPr>
+      <p:pic>
+        <p:nvPicPr>
+          <p:cNvPr id="2" name="Image 0" descr="ランキング (ranking) schematic sample">    </p:cNvPr>
+          <p:cNvPicPr>
+            <a:picLocks noChangeAspect="1"/>
+          </p:cNvPicPr>
+          <p:nvPr/>
+        </p:nvPicPr>
+        <p:blipFill>
+          <a:blip r:embed="rId1">
+            <a:extLst>
+              <a:ext uri="{96DAC541-7B7A-43D3-8B79-37D633B846F1}">
+                <asvg:svgBlip xmlns:asvg="http://schemas.microsoft.com/office/drawing/2016/SVG/main" r:embed="rId2"/>
+              </a:ext>
+            </a:extLst>
+          </a:blip>
+          <a:stretch>
+            <a:fillRect/>
+          </a:stretch>
+        </p:blipFill>
+        <p:spPr>
+          <a:xfrm>
+            <a:off x="0" y="0"/>
+            <a:ext cx="12191695" cy="6858000"/>
+          </a:xfrm>
+          <a:prstGeom prst="rect">
+            <a:avLst/>
+          </a:prstGeom>
+        </p:spPr>
+      </p:pic>
+    </p:spTree>
+  </p:cSld>
+  <p:clrMapOvr>
+    <a:masterClrMapping/>
+  </p:clrMapOvr>
+</p:sld>
+</file>
+
+<file path=ppt/slides/slide22.xml><?xml version="1.0" encoding="utf-8"?>
+<p:sld xmlns:a="http://schemas.openxmlformats.org/drawingml/2006/main" xmlns:r="http://schemas.openxmlformats.org/officeDocument/2006/relationships" xmlns:p="http://schemas.openxmlformats.org/presentationml/2006/main">
+  <p:cSld name="Slide 22">
+    <p:bg>
+      <p:bgPr>
+        <a:solidFill>
+          <a:srgbClr val="FFFFFF"/>
+        </a:solidFill>
+      </p:bgPr>
+    </p:bg>
+    <p:spTree>
+      <p:nvGrpSpPr>
+        <p:cNvPr id="1" name=""/>
+        <p:cNvGrpSpPr/>
+        <p:nvPr/>
+      </p:nvGrpSpPr>
+      <p:grpSpPr>
+        <a:xfrm>
+          <a:off x="0" y="0"/>
+          <a:ext cx="0" cy="0"/>
+          <a:chOff x="0" y="0"/>
+          <a:chExt cx="0" cy="0"/>
+        </a:xfrm>
+      </p:grpSpPr>
+      <p:pic>
+        <p:nvPicPr>
+          <p:cNvPr id="2" name="Image 0" descr="箇条書き縦 (list) schematic sample">    </p:cNvPr>
+          <p:cNvPicPr>
+            <a:picLocks noChangeAspect="1"/>
+          </p:cNvPicPr>
+          <p:nvPr/>
+        </p:nvPicPr>
+        <p:blipFill>
+          <a:blip r:embed="rId1">
+            <a:extLst>
+              <a:ext uri="{96DAC541-7B7A-43D3-8B79-37D633B846F1}">
+                <asvg:svgBlip xmlns:asvg="http://schemas.microsoft.com/office/drawing/2016/SVG/main" r:embed="rId2"/>
+              </a:ext>
+            </a:extLst>
+          </a:blip>
+          <a:stretch>
+            <a:fillRect/>
+          </a:stretch>
+        </p:blipFill>
+        <p:spPr>
+          <a:xfrm>
+            <a:off x="0" y="0"/>
+            <a:ext cx="12191695" cy="6858000"/>
+          </a:xfrm>
+          <a:prstGeom prst="rect">
+            <a:avLst/>
+          </a:prstGeom>
+        </p:spPr>
+      </p:pic>
+    </p:spTree>
+  </p:cSld>
+  <p:clrMapOvr>
+    <a:masterClrMapping/>
+  </p:clrMapOvr>
+</p:sld>
+</file>
+
+<file path=ppt/slides/slide23.xml><?xml version="1.0" encoding="utf-8"?>
+<p:sld xmlns:a="http://schemas.openxmlformats.org/drawingml/2006/main" xmlns:r="http://schemas.openxmlformats.org/officeDocument/2006/relationships" xmlns:p="http://schemas.openxmlformats.org/presentationml/2006/main">
+  <p:cSld name="Slide 23">
+    <p:bg>
+      <p:bgPr>
+        <a:solidFill>
+          <a:srgbClr val="FFFFFF"/>
+        </a:solidFill>
+      </p:bgPr>
+    </p:bg>
+    <p:spTree>
+      <p:nvGrpSpPr>
+        <p:cNvPr id="1" name=""/>
+        <p:cNvGrpSpPr/>
+        <p:nvPr/>
+      </p:nvGrpSpPr>
+      <p:grpSpPr>
+        <a:xfrm>
+          <a:off x="0" y="0"/>
+          <a:ext cx="0" cy="0"/>
+          <a:chOff x="0" y="0"/>
+          <a:chExt cx="0" cy="0"/>
+        </a:xfrm>
+      </p:grpSpPr>
+      <p:pic>
+        <p:nvPicPr>
+          <p:cNvPr id="2" name="Image 0" descr="箇条書き横 (list-horizontal) schematic sample">    </p:cNvPr>
+          <p:cNvPicPr>
+            <a:picLocks noChangeAspect="1"/>
+          </p:cNvPicPr>
+          <p:nvPr/>
+        </p:nvPicPr>
+        <p:blipFill>
+          <a:blip r:embed="rId1">
+            <a:extLst>
+              <a:ext uri="{96DAC541-7B7A-43D3-8B79-37D633B846F1}">
+                <asvg:svgBlip xmlns:asvg="http://schemas.microsoft.com/office/drawing/2016/SVG/main" r:embed="rId2"/>
+              </a:ext>
+            </a:extLst>
+          </a:blip>
+          <a:stretch>
+            <a:fillRect/>
+          </a:stretch>
+        </p:blipFill>
+        <p:spPr>
+          <a:xfrm>
+            <a:off x="0" y="0"/>
+            <a:ext cx="12191695" cy="6858000"/>
+          </a:xfrm>
+          <a:prstGeom prst="rect">
+            <a:avLst/>
+          </a:prstGeom>
+        </p:spPr>
+      </p:pic>
+    </p:spTree>
+  </p:cSld>
+  <p:clrMapOvr>
+    <a:masterClrMapping/>
+  </p:clrMapOvr>
+</p:sld>
+</file>
+
+<file path=ppt/slides/slide24.xml><?xml version="1.0" encoding="utf-8"?>
+<p:sld xmlns:a="http://schemas.openxmlformats.org/drawingml/2006/main" xmlns:r="http://schemas.openxmlformats.org/officeDocument/2006/relationships" xmlns:p="http://schemas.openxmlformats.org/presentationml/2006/main">
+  <p:cSld name="Slide 24">
+    <p:bg>
+      <p:bgPr>
+        <a:solidFill>
+          <a:srgbClr val="FFFFFF"/>
+        </a:solidFill>
+      </p:bgPr>
+    </p:bg>
+    <p:spTree>
+      <p:nvGrpSpPr>
+        <p:cNvPr id="1" name=""/>
+        <p:cNvGrpSpPr/>
+        <p:nvPr/>
+      </p:nvGrpSpPr>
+      <p:grpSpPr>
+        <a:xfrm>
+          <a:off x="0" y="0"/>
+          <a:ext cx="0" cy="0"/>
+          <a:chOff x="0" y="0"/>
+          <a:chExt cx="0" cy="0"/>
+        </a:xfrm>
+      </p:grpSpPr>
+      <p:pic>
+        <p:nvPicPr>
+          <p:cNvPr id="2" name="Image 0" descr="箇条書き羅列 (list-enumeration) schematic sample">    </p:cNvPr>
+          <p:cNvPicPr>
+            <a:picLocks noChangeAspect="1"/>
+          </p:cNvPicPr>
+          <p:nvPr/>
+        </p:nvPicPr>
+        <p:blipFill>
+          <a:blip r:embed="rId1">
+            <a:extLst>
+              <a:ext uri="{96DAC541-7B7A-43D3-8B79-37D633B846F1}">
+                <asvg:svgBlip xmlns:asvg="http://schemas.microsoft.com/office/drawing/2016/SVG/main" r:embed="rId2"/>
+              </a:ext>
+            </a:extLst>
+          </a:blip>
+          <a:stretch>
+            <a:fillRect/>
+          </a:stretch>
+        </p:blipFill>
+        <p:spPr>
+          <a:xfrm>
+            <a:off x="0" y="0"/>
+            <a:ext cx="12191695" cy="6858000"/>
+          </a:xfrm>
+          <a:prstGeom prst="rect">
+            <a:avLst/>
+          </a:prstGeom>
+        </p:spPr>
+      </p:pic>
+    </p:spTree>
+  </p:cSld>
+  <p:clrMapOvr>
+    <a:masterClrMapping/>
+  </p:clrMapOvr>
+</p:sld>
+</file>
+
+<file path=ppt/slides/slide25.xml><?xml version="1.0" encoding="utf-8"?>
+<p:sld xmlns:a="http://schemas.openxmlformats.org/drawingml/2006/main" xmlns:r="http://schemas.openxmlformats.org/officeDocument/2006/relationships" xmlns:p="http://schemas.openxmlformats.org/presentationml/2006/main">
+  <p:cSld name="Slide 25">
+    <p:bg>
+      <p:bgPr>
+        <a:solidFill>
+          <a:srgbClr val="FFFFFF"/>
+        </a:solidFill>
+      </p:bgPr>
+    </p:bg>
+    <p:spTree>
+      <p:nvGrpSpPr>
+        <p:cNvPr id="1" name=""/>
+        <p:cNvGrpSpPr/>
+        <p:nvPr/>
+      </p:nvGrpSpPr>
+      <p:grpSpPr>
+        <a:xfrm>
+          <a:off x="0" y="0"/>
+          <a:ext cx="0" cy="0"/>
+          <a:chOff x="0" y="0"/>
+          <a:chExt cx="0" cy="0"/>
+        </a:xfrm>
+      </p:grpSpPr>
+      <p:pic>
+        <p:nvPicPr>
+          <p:cNvPr id="2" name="Image 0" descr="モックアップ (mockup) schematic sample">    </p:cNvPr>
+          <p:cNvPicPr>
+            <a:picLocks noChangeAspect="1"/>
+          </p:cNvPicPr>
+          <p:nvPr/>
+        </p:nvPicPr>
+        <p:blipFill>
+          <a:blip r:embed="rId1">
+            <a:extLst>
+              <a:ext uri="{96DAC541-7B7A-43D3-8B79-37D633B846F1}">
+                <asvg:svgBlip xmlns:asvg="http://schemas.microsoft.com/office/drawing/2016/SVG/main" r:embed="rId2"/>
+              </a:ext>
+            </a:extLst>
+          </a:blip>
+          <a:stretch>
+            <a:fillRect/>
+          </a:stretch>
+        </p:blipFill>
+        <p:spPr>
+          <a:xfrm>
+            <a:off x="0" y="0"/>
+            <a:ext cx="12191695" cy="6858000"/>
+          </a:xfrm>
+          <a:prstGeom prst="rect">
+            <a:avLst/>
+          </a:prstGeom>
+        </p:spPr>
+      </p:pic>
+    </p:spTree>
+  </p:cSld>
+  <p:clrMapOvr>
+    <a:masterClrMapping/>
+  </p:clrMapOvr>
+</p:sld>
+</file>
+
+<file path=ppt/slides/slide26.xml><?xml version="1.0" encoding="utf-8"?>
+<p:sld xmlns:a="http://schemas.openxmlformats.org/drawingml/2006/main" xmlns:r="http://schemas.openxmlformats.org/officeDocument/2006/relationships" xmlns:p="http://schemas.openxmlformats.org/presentationml/2006/main">
+  <p:cSld name="Slide 26">
     <p:bg>
       <p:bgPr>
         <a:solidFill>
@@ -1627,12 +4427,446 @@
                 <a:ea typeface="Yu Gothic" pitchFamily="34" charset="-122"/>
                 <a:cs typeface="Yu Gothic" pitchFamily="34" charset="-120"/>
               </a:rPr>
-              <a:t>https://www.slideland.tech/</a:t>
+              <a:t>https://www.slideland.tech/docs/schematic</a:t>
             </a:r>
             <a:endParaRPr lang="en-US" sz="1400" dirty="0"/>
           </a:p>
         </p:txBody>
       </p:sp>
+    </p:spTree>
+  </p:cSld>
+  <p:clrMapOvr>
+    <a:masterClrMapping/>
+  </p:clrMapOvr>
+</p:sld>
+</file>
+
+<file path=ppt/slides/slide3.xml><?xml version="1.0" encoding="utf-8"?>
+<p:sld xmlns:a="http://schemas.openxmlformats.org/drawingml/2006/main" xmlns:r="http://schemas.openxmlformats.org/officeDocument/2006/relationships" xmlns:p="http://schemas.openxmlformats.org/presentationml/2006/main">
+  <p:cSld name="Slide 3">
+    <p:bg>
+      <p:bgPr>
+        <a:solidFill>
+          <a:srgbClr val="FFFFFF"/>
+        </a:solidFill>
+      </p:bgPr>
+    </p:bg>
+    <p:spTree>
+      <p:nvGrpSpPr>
+        <p:cNvPr id="1" name=""/>
+        <p:cNvGrpSpPr/>
+        <p:nvPr/>
+      </p:nvGrpSpPr>
+      <p:grpSpPr>
+        <a:xfrm>
+          <a:off x="0" y="0"/>
+          <a:ext cx="0" cy="0"/>
+          <a:chOff x="0" y="0"/>
+          <a:chExt cx="0" cy="0"/>
+        </a:xfrm>
+      </p:grpSpPr>
+      <p:pic>
+        <p:nvPicPr>
+          <p:cNvPr id="2" name="Image 0" descr="横フロー (flow) schematic sample">    </p:cNvPr>
+          <p:cNvPicPr>
+            <a:picLocks noChangeAspect="1"/>
+          </p:cNvPicPr>
+          <p:nvPr/>
+        </p:nvPicPr>
+        <p:blipFill>
+          <a:blip r:embed="rId1">
+            <a:extLst>
+              <a:ext uri="{96DAC541-7B7A-43D3-8B79-37D633B846F1}">
+                <asvg:svgBlip xmlns:asvg="http://schemas.microsoft.com/office/drawing/2016/SVG/main" r:embed="rId2"/>
+              </a:ext>
+            </a:extLst>
+          </a:blip>
+          <a:stretch>
+            <a:fillRect/>
+          </a:stretch>
+        </p:blipFill>
+        <p:spPr>
+          <a:xfrm>
+            <a:off x="0" y="0"/>
+            <a:ext cx="12191695" cy="6858000"/>
+          </a:xfrm>
+          <a:prstGeom prst="rect">
+            <a:avLst/>
+          </a:prstGeom>
+        </p:spPr>
+      </p:pic>
+    </p:spTree>
+  </p:cSld>
+  <p:clrMapOvr>
+    <a:masterClrMapping/>
+  </p:clrMapOvr>
+</p:sld>
+</file>
+
+<file path=ppt/slides/slide4.xml><?xml version="1.0" encoding="utf-8"?>
+<p:sld xmlns:a="http://schemas.openxmlformats.org/drawingml/2006/main" xmlns:r="http://schemas.openxmlformats.org/officeDocument/2006/relationships" xmlns:p="http://schemas.openxmlformats.org/presentationml/2006/main">
+  <p:cSld name="Slide 4">
+    <p:bg>
+      <p:bgPr>
+        <a:solidFill>
+          <a:srgbClr val="FFFFFF"/>
+        </a:solidFill>
+      </p:bgPr>
+    </p:bg>
+    <p:spTree>
+      <p:nvGrpSpPr>
+        <p:cNvPr id="1" name=""/>
+        <p:cNvGrpSpPr/>
+        <p:nvPr/>
+      </p:nvGrpSpPr>
+      <p:grpSpPr>
+        <a:xfrm>
+          <a:off x="0" y="0"/>
+          <a:ext cx="0" cy="0"/>
+          <a:chOff x="0" y="0"/>
+          <a:chExt cx="0" cy="0"/>
+        </a:xfrm>
+      </p:grpSpPr>
+      <p:pic>
+        <p:nvPicPr>
+          <p:cNvPr id="2" name="Image 0" descr="縦フロー (vertical-flow) schematic sample">    </p:cNvPr>
+          <p:cNvPicPr>
+            <a:picLocks noChangeAspect="1"/>
+          </p:cNvPicPr>
+          <p:nvPr/>
+        </p:nvPicPr>
+        <p:blipFill>
+          <a:blip r:embed="rId1">
+            <a:extLst>
+              <a:ext uri="{96DAC541-7B7A-43D3-8B79-37D633B846F1}">
+                <asvg:svgBlip xmlns:asvg="http://schemas.microsoft.com/office/drawing/2016/SVG/main" r:embed="rId2"/>
+              </a:ext>
+            </a:extLst>
+          </a:blip>
+          <a:stretch>
+            <a:fillRect/>
+          </a:stretch>
+        </p:blipFill>
+        <p:spPr>
+          <a:xfrm>
+            <a:off x="0" y="0"/>
+            <a:ext cx="12191695" cy="6858000"/>
+          </a:xfrm>
+          <a:prstGeom prst="rect">
+            <a:avLst/>
+          </a:prstGeom>
+        </p:spPr>
+      </p:pic>
+    </p:spTree>
+  </p:cSld>
+  <p:clrMapOvr>
+    <a:masterClrMapping/>
+  </p:clrMapOvr>
+</p:sld>
+</file>
+
+<file path=ppt/slides/slide5.xml><?xml version="1.0" encoding="utf-8"?>
+<p:sld xmlns:a="http://schemas.openxmlformats.org/drawingml/2006/main" xmlns:r="http://schemas.openxmlformats.org/officeDocument/2006/relationships" xmlns:p="http://schemas.openxmlformats.org/presentationml/2006/main">
+  <p:cSld name="Slide 5">
+    <p:bg>
+      <p:bgPr>
+        <a:solidFill>
+          <a:srgbClr val="FFFFFF"/>
+        </a:solidFill>
+      </p:bgPr>
+    </p:bg>
+    <p:spTree>
+      <p:nvGrpSpPr>
+        <p:cNvPr id="1" name=""/>
+        <p:cNvGrpSpPr/>
+        <p:nvPr/>
+      </p:nvGrpSpPr>
+      <p:grpSpPr>
+        <a:xfrm>
+          <a:off x="0" y="0"/>
+          <a:ext cx="0" cy="0"/>
+          <a:chOff x="0" y="0"/>
+          <a:chExt cx="0" cy="0"/>
+        </a:xfrm>
+      </p:grpSpPr>
+      <p:pic>
+        <p:nvPicPr>
+          <p:cNvPr id="2" name="Image 0" descr="サイクル (cycle) schematic sample">    </p:cNvPr>
+          <p:cNvPicPr>
+            <a:picLocks noChangeAspect="1"/>
+          </p:cNvPicPr>
+          <p:nvPr/>
+        </p:nvPicPr>
+        <p:blipFill>
+          <a:blip r:embed="rId1">
+            <a:extLst>
+              <a:ext uri="{96DAC541-7B7A-43D3-8B79-37D633B846F1}">
+                <asvg:svgBlip xmlns:asvg="http://schemas.microsoft.com/office/drawing/2016/SVG/main" r:embed="rId2"/>
+              </a:ext>
+            </a:extLst>
+          </a:blip>
+          <a:stretch>
+            <a:fillRect/>
+          </a:stretch>
+        </p:blipFill>
+        <p:spPr>
+          <a:xfrm>
+            <a:off x="0" y="0"/>
+            <a:ext cx="12191695" cy="6858000"/>
+          </a:xfrm>
+          <a:prstGeom prst="rect">
+            <a:avLst/>
+          </a:prstGeom>
+        </p:spPr>
+      </p:pic>
+    </p:spTree>
+  </p:cSld>
+  <p:clrMapOvr>
+    <a:masterClrMapping/>
+  </p:clrMapOvr>
+</p:sld>
+</file>
+
+<file path=ppt/slides/slide6.xml><?xml version="1.0" encoding="utf-8"?>
+<p:sld xmlns:a="http://schemas.openxmlformats.org/drawingml/2006/main" xmlns:r="http://schemas.openxmlformats.org/officeDocument/2006/relationships" xmlns:p="http://schemas.openxmlformats.org/presentationml/2006/main">
+  <p:cSld name="Slide 6">
+    <p:bg>
+      <p:bgPr>
+        <a:solidFill>
+          <a:srgbClr val="FFFFFF"/>
+        </a:solidFill>
+      </p:bgPr>
+    </p:bg>
+    <p:spTree>
+      <p:nvGrpSpPr>
+        <p:cNvPr id="1" name=""/>
+        <p:cNvGrpSpPr/>
+        <p:nvPr/>
+      </p:nvGrpSpPr>
+      <p:grpSpPr>
+        <a:xfrm>
+          <a:off x="0" y="0"/>
+          <a:ext cx="0" cy="0"/>
+          <a:chOff x="0" y="0"/>
+          <a:chExt cx="0" cy="0"/>
+        </a:xfrm>
+      </p:grpSpPr>
+      <p:pic>
+        <p:nvPicPr>
+          <p:cNvPr id="2" name="Image 0" descr="前後比較 (before-after) schematic sample">    </p:cNvPr>
+          <p:cNvPicPr>
+            <a:picLocks noChangeAspect="1"/>
+          </p:cNvPicPr>
+          <p:nvPr/>
+        </p:nvPicPr>
+        <p:blipFill>
+          <a:blip r:embed="rId1">
+            <a:extLst>
+              <a:ext uri="{96DAC541-7B7A-43D3-8B79-37D633B846F1}">
+                <asvg:svgBlip xmlns:asvg="http://schemas.microsoft.com/office/drawing/2016/SVG/main" r:embed="rId2"/>
+              </a:ext>
+            </a:extLst>
+          </a:blip>
+          <a:stretch>
+            <a:fillRect/>
+          </a:stretch>
+        </p:blipFill>
+        <p:spPr>
+          <a:xfrm>
+            <a:off x="0" y="0"/>
+            <a:ext cx="12191695" cy="6858000"/>
+          </a:xfrm>
+          <a:prstGeom prst="rect">
+            <a:avLst/>
+          </a:prstGeom>
+        </p:spPr>
+      </p:pic>
+    </p:spTree>
+  </p:cSld>
+  <p:clrMapOvr>
+    <a:masterClrMapping/>
+  </p:clrMapOvr>
+</p:sld>
+</file>
+
+<file path=ppt/slides/slide7.xml><?xml version="1.0" encoding="utf-8"?>
+<p:sld xmlns:a="http://schemas.openxmlformats.org/drawingml/2006/main" xmlns:r="http://schemas.openxmlformats.org/officeDocument/2006/relationships" xmlns:p="http://schemas.openxmlformats.org/presentationml/2006/main">
+  <p:cSld name="Slide 7">
+    <p:bg>
+      <p:bgPr>
+        <a:solidFill>
+          <a:srgbClr val="FFFFFF"/>
+        </a:solidFill>
+      </p:bgPr>
+    </p:bg>
+    <p:spTree>
+      <p:nvGrpSpPr>
+        <p:cNvPr id="1" name=""/>
+        <p:cNvGrpSpPr/>
+        <p:nvPr/>
+      </p:nvGrpSpPr>
+      <p:grpSpPr>
+        <a:xfrm>
+          <a:off x="0" y="0"/>
+          <a:ext cx="0" cy="0"/>
+          <a:chOff x="0" y="0"/>
+          <a:chExt cx="0" cy="0"/>
+        </a:xfrm>
+      </p:grpSpPr>
+      <p:pic>
+        <p:nvPicPr>
+          <p:cNvPr id="2" name="Image 0" descr="マップ (map) schematic sample">    </p:cNvPr>
+          <p:cNvPicPr>
+            <a:picLocks noChangeAspect="1"/>
+          </p:cNvPicPr>
+          <p:nvPr/>
+        </p:nvPicPr>
+        <p:blipFill>
+          <a:blip r:embed="rId1">
+            <a:extLst>
+              <a:ext uri="{96DAC541-7B7A-43D3-8B79-37D633B846F1}">
+                <asvg:svgBlip xmlns:asvg="http://schemas.microsoft.com/office/drawing/2016/SVG/main" r:embed="rId2"/>
+              </a:ext>
+            </a:extLst>
+          </a:blip>
+          <a:stretch>
+            <a:fillRect/>
+          </a:stretch>
+        </p:blipFill>
+        <p:spPr>
+          <a:xfrm>
+            <a:off x="0" y="0"/>
+            <a:ext cx="12191695" cy="6858000"/>
+          </a:xfrm>
+          <a:prstGeom prst="rect">
+            <a:avLst/>
+          </a:prstGeom>
+        </p:spPr>
+      </p:pic>
+    </p:spTree>
+  </p:cSld>
+  <p:clrMapOvr>
+    <a:masterClrMapping/>
+  </p:clrMapOvr>
+</p:sld>
+</file>
+
+<file path=ppt/slides/slide8.xml><?xml version="1.0" encoding="utf-8"?>
+<p:sld xmlns:a="http://schemas.openxmlformats.org/drawingml/2006/main" xmlns:r="http://schemas.openxmlformats.org/officeDocument/2006/relationships" xmlns:p="http://schemas.openxmlformats.org/presentationml/2006/main">
+  <p:cSld name="Slide 8">
+    <p:bg>
+      <p:bgPr>
+        <a:solidFill>
+          <a:srgbClr val="FFFFFF"/>
+        </a:solidFill>
+      </p:bgPr>
+    </p:bg>
+    <p:spTree>
+      <p:nvGrpSpPr>
+        <p:cNvPr id="1" name=""/>
+        <p:cNvGrpSpPr/>
+        <p:nvPr/>
+      </p:nvGrpSpPr>
+      <p:grpSpPr>
+        <a:xfrm>
+          <a:off x="0" y="0"/>
+          <a:ext cx="0" cy="0"/>
+          <a:chOff x="0" y="0"/>
+          <a:chExt cx="0" cy="0"/>
+        </a:xfrm>
+      </p:grpSpPr>
+      <p:pic>
+        <p:nvPicPr>
+          <p:cNvPr id="2" name="Image 0" descr="パズル/ハニカム (puzzle) schematic sample">    </p:cNvPr>
+          <p:cNvPicPr>
+            <a:picLocks noChangeAspect="1"/>
+          </p:cNvPicPr>
+          <p:nvPr/>
+        </p:nvPicPr>
+        <p:blipFill>
+          <a:blip r:embed="rId1">
+            <a:extLst>
+              <a:ext uri="{96DAC541-7B7A-43D3-8B79-37D633B846F1}">
+                <asvg:svgBlip xmlns:asvg="http://schemas.microsoft.com/office/drawing/2016/SVG/main" r:embed="rId2"/>
+              </a:ext>
+            </a:extLst>
+          </a:blip>
+          <a:stretch>
+            <a:fillRect/>
+          </a:stretch>
+        </p:blipFill>
+        <p:spPr>
+          <a:xfrm>
+            <a:off x="0" y="0"/>
+            <a:ext cx="12191695" cy="6858000"/>
+          </a:xfrm>
+          <a:prstGeom prst="rect">
+            <a:avLst/>
+          </a:prstGeom>
+        </p:spPr>
+      </p:pic>
+    </p:spTree>
+  </p:cSld>
+  <p:clrMapOvr>
+    <a:masterClrMapping/>
+  </p:clrMapOvr>
+</p:sld>
+</file>
+
+<file path=ppt/slides/slide9.xml><?xml version="1.0" encoding="utf-8"?>
+<p:sld xmlns:a="http://schemas.openxmlformats.org/drawingml/2006/main" xmlns:r="http://schemas.openxmlformats.org/officeDocument/2006/relationships" xmlns:p="http://schemas.openxmlformats.org/presentationml/2006/main">
+  <p:cSld name="Slide 9">
+    <p:bg>
+      <p:bgPr>
+        <a:solidFill>
+          <a:srgbClr val="FFFFFF"/>
+        </a:solidFill>
+      </p:bgPr>
+    </p:bg>
+    <p:spTree>
+      <p:nvGrpSpPr>
+        <p:cNvPr id="1" name=""/>
+        <p:cNvGrpSpPr/>
+        <p:nvPr/>
+      </p:nvGrpSpPr>
+      <p:grpSpPr>
+        <a:xfrm>
+          <a:off x="0" y="0"/>
+          <a:ext cx="0" cy="0"/>
+          <a:chOff x="0" y="0"/>
+          <a:chExt cx="0" cy="0"/>
+        </a:xfrm>
+      </p:grpSpPr>
+      <p:pic>
+        <p:nvPicPr>
+          <p:cNvPr id="2" name="Image 0" descr="相関図/概念図 (correlation) schematic sample">    </p:cNvPr>
+          <p:cNvPicPr>
+            <a:picLocks noChangeAspect="1"/>
+          </p:cNvPicPr>
+          <p:nvPr/>
+        </p:nvPicPr>
+        <p:blipFill>
+          <a:blip r:embed="rId1">
+            <a:extLst>
+              <a:ext uri="{96DAC541-7B7A-43D3-8B79-37D633B846F1}">
+                <asvg:svgBlip xmlns:asvg="http://schemas.microsoft.com/office/drawing/2016/SVG/main" r:embed="rId2"/>
+              </a:ext>
+            </a:extLst>
+          </a:blip>
+          <a:stretch>
+            <a:fillRect/>
+          </a:stretch>
+        </p:blipFill>
+        <p:spPr>
+          <a:xfrm>
+            <a:off x="0" y="0"/>
+            <a:ext cx="12191695" cy="6858000"/>
+          </a:xfrm>
+          <a:prstGeom prst="rect">
+            <a:avLst/>
+          </a:prstGeom>
+        </p:spPr>
+      </p:pic>
     </p:spTree>
   </p:cSld>
   <p:clrMapOvr>

</xml_diff>